<commit_message>
Agrega Programa de Cursos Octubre 2026 y materiales de clase recientes
- Programa_Cursos_Octubre_2026 (docx + pdf): documento del estudiante
  con la escalera completa de octubre (Basico 1 / Basico 2 /
  Conversacional con Abby), cronogramas sesion por sesion con fechas,
  precios, politicas e inscripcion
- Plan_Cursos_2026-2_y_Comisiones (docx + pdf): plan interno de los
  dos cursos nuevos y modelo de comisiones para profesores
- Materiales de Sesion 5 (numeros, fechas y hora; lista de contadores;
  one-pager sino vs nativo) y Sesion 8 Comprar (pptx actualizado + pdf);
  se elimina el borrador v4 de Fechas/Numeros reemplazado por la
  version nueva
- Clases individuales recientes (Clase 가요 260822, clase juby 260830)

Co-Authored-By: Claude Fable 5 <noreply@anthropic.com>
</commit_message>
<xml_diff>
--- a/A1_Nivel_1/08_Comprar/Sesion_08_Comprar.pptx
+++ b/A1_Nivel_1/08_Comprar/Sesion_08_Comprar.pptx
@@ -4,6 +4,9 @@
   <p:sldMasterIdLst>
     <p:sldMasterId id="2147483648" r:id="rId1"/>
   </p:sldMasterIdLst>
+  <p:notesMasterIdLst>
+    <p:notesMasterId r:id="rId14"/>
+  </p:notesMasterIdLst>
   <p:sldIdLst>
     <p:sldId id="256" r:id="rId2"/>
     <p:sldId id="257" r:id="rId3"/>
@@ -18,9 +21,6 @@
     <p:sldId id="266" r:id="rId12"/>
     <p:sldId id="267" r:id="rId13"/>
   </p:sldIdLst>
-  <p:notesMasterIdLst>
-    <p:notesMasterId r:id="rId14"/>
-  </p:notesMasterIdLst>
   <p:sldSz cx="12192000" cy="6858000"/>
   <p:notesSz cx="6858000" cy="12192000"/>
   <p:defaultTextStyle>
@@ -115,6 +115,11 @@
       </a:defRPr>
     </a:lvl9pPr>
   </p:defaultTextStyle>
+  <p:extLst>
+    <p:ext uri="{EFAFB233-063F-42B5-8137-9DF3F51BA10A}">
+      <p15:sldGuideLst xmlns:p15="http://schemas.microsoft.com/office/powerpoint/2012/main"/>
+    </p:ext>
+  </p:extLst>
 </p:presentation>
 </file>
 
@@ -140,234 +145,10 @@
           <a:chExt cx="0" cy="0"/>
         </a:xfrm>
       </p:grpSpPr>
-      <p:sp>
-        <p:nvSpPr>
-          <p:cNvPr id="2" name="Header Placeholder 1"/>
-          <p:cNvSpPr>
-            <a:spLocks noGrp="1"/>
-          </p:cNvSpPr>
-          <p:nvPr>
-            <p:ph type="hdr" sz="quarter"/>
-          </p:nvPr>
-        </p:nvSpPr>
-        <p:spPr>
-          <a:xfrm>
-            <a:off x="0" y="0"/>
-            <a:ext cx="2971800" cy="458788"/>
-          </a:xfrm>
-          <a:prstGeom prst="rect">
-            <a:avLst/>
-          </a:prstGeom>
-        </p:spPr>
-        <p:txBody>
-          <a:bodyPr vert="horz" lIns="91440" tIns="45720" rIns="91440" bIns="45720" rtlCol="0"/>
-          <a:lstStyle>
-            <a:lvl1pPr algn="l">
-              <a:defRPr sz="1200"/>
-            </a:lvl1pPr>
-          </a:lstStyle>
-          <a:p>
-            <a:endParaRPr lang="en-US"/>
-          </a:p>
-        </p:txBody>
-      </p:sp>
-      <p:sp>
-        <p:nvSpPr>
-          <p:cNvPr id="3" name="Date Placeholder 2"/>
-          <p:cNvSpPr>
-            <a:spLocks noGrp="1"/>
-          </p:cNvSpPr>
-          <p:nvPr>
-            <p:ph type="dt" idx="1"/>
-          </p:nvPr>
-        </p:nvSpPr>
-        <p:spPr>
-          <a:xfrm>
-            <a:off x="3884613" y="0"/>
-            <a:ext cx="2971800" cy="458788"/>
-          </a:xfrm>
-          <a:prstGeom prst="rect">
-            <a:avLst/>
-          </a:prstGeom>
-        </p:spPr>
-        <p:txBody>
-          <a:bodyPr vert="horz" lIns="91440" tIns="45720" rIns="91440" bIns="45720" rtlCol="0"/>
-          <a:lstStyle>
-            <a:lvl1pPr algn="r">
-              <a:defRPr sz="1200"/>
-            </a:lvl1pPr>
-          </a:lstStyle>
-          <a:p>
-            <a:fld id="{5282F153-3F37-0F45-9E97-73ACFA13230C}" type="datetimeFigureOut">
-              <a:rPr lang="en-US"/>
-              <a:t>7/23/19</a:t>
-            </a:fld>
-            <a:endParaRPr lang="en-US"/>
-          </a:p>
-        </p:txBody>
-      </p:sp>
-      <p:sp>
-        <p:nvSpPr>
-          <p:cNvPr id="4" name="Slide Image Placeholder 3"/>
-          <p:cNvSpPr>
-            <a:spLocks noGrp="1" noRot="1" noChangeAspect="1"/>
-          </p:cNvSpPr>
-          <p:nvPr>
-            <p:ph type="sldImg" idx="2"/>
-          </p:nvPr>
-        </p:nvSpPr>
-        <p:spPr>
-          <a:xfrm>
-            <a:off x="685800" y="1143000"/>
-            <a:ext cx="5486400" cy="3086100"/>
-          </a:xfrm>
-          <a:prstGeom prst="rect">
-            <a:avLst/>
-          </a:prstGeom>
-          <a:noFill/>
-          <a:ln w="12700">
-            <a:solidFill>
-              <a:prstClr val="black"/>
-            </a:solidFill>
-          </a:ln>
-        </p:spPr>
-        <p:txBody>
-          <a:bodyPr vert="horz" lIns="91440" tIns="45720" rIns="91440" bIns="45720" rtlCol="0" anchor="ctr"/>
-          <a:lstStyle/>
-          <a:p>
-            <a:endParaRPr lang="en-US"/>
-          </a:p>
-        </p:txBody>
-      </p:sp>
-      <p:sp>
-        <p:nvSpPr>
-          <p:cNvPr id="5" name="Notes Placeholder 4"/>
-          <p:cNvSpPr>
-            <a:spLocks noGrp="1"/>
-          </p:cNvSpPr>
-          <p:nvPr>
-            <p:ph type="body" sz="quarter" idx="3"/>
-          </p:nvPr>
-        </p:nvSpPr>
-        <p:spPr>
-          <a:xfrm>
-            <a:off x="685800" y="4400550"/>
-            <a:ext cx="5486400" cy="3600450"/>
-          </a:xfrm>
-          <a:prstGeom prst="rect">
-            <a:avLst/>
-          </a:prstGeom>
-        </p:spPr>
-        <p:txBody>
-          <a:bodyPr vert="horz" lIns="91440" tIns="45720" rIns="91440" bIns="45720" rtlCol="0"/>
-          <a:lstStyle/>
-          <a:p>
-            <a:pPr lvl="0"/>
-            <a:r>
-              <a:rPr lang="en-US"/>
-              <a:t>Click to edit Master text styles</a:t>
-            </a:r>
-          </a:p>
-          <a:p>
-            <a:pPr lvl="1"/>
-            <a:r>
-              <a:rPr lang="en-US"/>
-              <a:t>Second level</a:t>
-            </a:r>
-          </a:p>
-          <a:p>
-            <a:pPr lvl="2"/>
-            <a:r>
-              <a:rPr lang="en-US"/>
-              <a:t>Third level</a:t>
-            </a:r>
-          </a:p>
-          <a:p>
-            <a:pPr lvl="3"/>
-            <a:r>
-              <a:rPr lang="en-US"/>
-              <a:t>Fourth level</a:t>
-            </a:r>
-          </a:p>
-          <a:p>
-            <a:pPr lvl="4"/>
-            <a:r>
-              <a:rPr lang="en-US"/>
-              <a:t>Fifth level</a:t>
-            </a:r>
-          </a:p>
-        </p:txBody>
-      </p:sp>
-      <p:sp>
-        <p:nvSpPr>
-          <p:cNvPr id="6" name="Footer Placeholder 5"/>
-          <p:cNvSpPr>
-            <a:spLocks noGrp="1"/>
-          </p:cNvSpPr>
-          <p:nvPr>
-            <p:ph type="ftr" sz="quarter" idx="4"/>
-          </p:nvPr>
-        </p:nvSpPr>
-        <p:spPr>
-          <a:xfrm>
-            <a:off x="0" y="8685213"/>
-            <a:ext cx="2971800" cy="458787"/>
-          </a:xfrm>
-          <a:prstGeom prst="rect">
-            <a:avLst/>
-          </a:prstGeom>
-        </p:spPr>
-        <p:txBody>
-          <a:bodyPr vert="horz" lIns="91440" tIns="45720" rIns="91440" bIns="45720" rtlCol="0" anchor="b"/>
-          <a:lstStyle>
-            <a:lvl1pPr algn="l">
-              <a:defRPr sz="1200"/>
-            </a:lvl1pPr>
-          </a:lstStyle>
-          <a:p>
-            <a:endParaRPr lang="en-US"/>
-          </a:p>
-        </p:txBody>
-      </p:sp>
-      <p:sp>
-        <p:nvSpPr>
-          <p:cNvPr id="7" name="Slide Number Placeholder 6"/>
-          <p:cNvSpPr>
-            <a:spLocks noGrp="1"/>
-          </p:cNvSpPr>
-          <p:nvPr>
-            <p:ph type="sldNum" sz="quarter" idx="5"/>
-          </p:nvPr>
-        </p:nvSpPr>
-        <p:spPr>
-          <a:xfrm>
-            <a:off x="3884613" y="8685213"/>
-            <a:ext cx="2971800" cy="458787"/>
-          </a:xfrm>
-          <a:prstGeom prst="rect">
-            <a:avLst/>
-          </a:prstGeom>
-        </p:spPr>
-        <p:txBody>
-          <a:bodyPr vert="horz" lIns="91440" tIns="45720" rIns="91440" bIns="45720" rtlCol="0" anchor="b"/>
-          <a:lstStyle>
-            <a:lvl1pPr algn="r">
-              <a:defRPr sz="1200"/>
-            </a:lvl1pPr>
-          </a:lstStyle>
-          <a:p>
-            <a:fld id="{CE5E9CC1-C706-0F49-92D6-E571CC5EEA8F}" type="slidenum">
-              <a:rPr lang="en-US"/>
-              <a:t>‹#›</a:t>
-            </a:fld>
-            <a:endParaRPr lang="en-US"/>
-          </a:p>
-        </p:txBody>
-      </p:sp>
     </p:spTree>
     <p:extLst>
       <p:ext uri="{BB962C8B-B14F-4D97-AF65-F5344CB8AC3E}">
-        <p14:creationId xmlns:p14="http://schemas.microsoft.com/office/powerpoint/2010/main" val="1024086991"/>
+        <p14:creationId xmlns:p14="http://schemas.microsoft.com/office/powerpoint/2010/main" val="2557373368"/>
       </p:ext>
     </p:extLst>
   </p:cSld>
@@ -511,10 +292,6 @@
           <a:bodyPr/>
           <a:lstStyle/>
           <a:p>
-            <a:r>
-              <a:rPr lang="en-US" dirty="0"/>
-              <a:t/>
-            </a:r>
             <a:endParaRPr lang="en-US" dirty="0"/>
           </a:p>
         </p:txBody>
@@ -599,10 +376,6 @@
           <a:bodyPr/>
           <a:lstStyle/>
           <a:p>
-            <a:r>
-              <a:rPr lang="en-US" dirty="0"/>
-              <a:t/>
-            </a:r>
             <a:endParaRPr lang="en-US" dirty="0"/>
           </a:p>
         </p:txBody>
@@ -687,10 +460,6 @@
           <a:bodyPr/>
           <a:lstStyle/>
           <a:p>
-            <a:r>
-              <a:rPr lang="en-US" dirty="0"/>
-              <a:t/>
-            </a:r>
             <a:endParaRPr lang="en-US" dirty="0"/>
           </a:p>
         </p:txBody>
@@ -775,10 +544,6 @@
           <a:bodyPr/>
           <a:lstStyle/>
           <a:p>
-            <a:r>
-              <a:rPr lang="en-US" dirty="0"/>
-              <a:t/>
-            </a:r>
             <a:endParaRPr lang="en-US" dirty="0"/>
           </a:p>
         </p:txBody>
@@ -863,10 +628,6 @@
           <a:bodyPr/>
           <a:lstStyle/>
           <a:p>
-            <a:r>
-              <a:rPr lang="en-US" dirty="0"/>
-              <a:t/>
-            </a:r>
             <a:endParaRPr lang="en-US" dirty="0"/>
           </a:p>
         </p:txBody>
@@ -951,10 +712,6 @@
           <a:bodyPr/>
           <a:lstStyle/>
           <a:p>
-            <a:r>
-              <a:rPr lang="en-US" dirty="0"/>
-              <a:t/>
-            </a:r>
             <a:endParaRPr lang="en-US" dirty="0"/>
           </a:p>
         </p:txBody>
@@ -1039,10 +796,6 @@
           <a:bodyPr/>
           <a:lstStyle/>
           <a:p>
-            <a:r>
-              <a:rPr lang="en-US" dirty="0"/>
-              <a:t/>
-            </a:r>
             <a:endParaRPr lang="en-US" dirty="0"/>
           </a:p>
         </p:txBody>
@@ -1127,10 +880,6 @@
           <a:bodyPr/>
           <a:lstStyle/>
           <a:p>
-            <a:r>
-              <a:rPr lang="en-US" dirty="0"/>
-              <a:t/>
-            </a:r>
             <a:endParaRPr lang="en-US" dirty="0"/>
           </a:p>
         </p:txBody>
@@ -1215,10 +964,6 @@
           <a:bodyPr/>
           <a:lstStyle/>
           <a:p>
-            <a:r>
-              <a:rPr lang="en-US" dirty="0"/>
-              <a:t/>
-            </a:r>
             <a:endParaRPr lang="en-US" dirty="0"/>
           </a:p>
         </p:txBody>
@@ -1303,10 +1048,6 @@
           <a:bodyPr/>
           <a:lstStyle/>
           <a:p>
-            <a:r>
-              <a:rPr lang="en-US" dirty="0"/>
-              <a:t/>
-            </a:r>
             <a:endParaRPr lang="en-US" dirty="0"/>
           </a:p>
         </p:txBody>
@@ -1391,10 +1132,6 @@
           <a:bodyPr/>
           <a:lstStyle/>
           <a:p>
-            <a:r>
-              <a:rPr lang="en-US" dirty="0"/>
-              <a:t/>
-            </a:r>
             <a:endParaRPr lang="en-US" dirty="0"/>
           </a:p>
         </p:txBody>
@@ -1479,10 +1216,6 @@
           <a:bodyPr/>
           <a:lstStyle/>
           <a:p>
-            <a:r>
-              <a:rPr lang="en-US" dirty="0"/>
-              <a:t/>
-            </a:r>
             <a:endParaRPr lang="en-US" dirty="0"/>
           </a:p>
         </p:txBody>
@@ -1556,6 +1289,11 @@
 <file path=ppt/slideMasters/slideMaster1.xml><?xml version="1.0" encoding="utf-8"?>
 <p:sldMaster xmlns:a="http://schemas.openxmlformats.org/drawingml/2006/main" xmlns:r="http://schemas.openxmlformats.org/officeDocument/2006/relationships" xmlns:p="http://schemas.openxmlformats.org/presentationml/2006/main">
   <p:cSld>
+    <p:bg>
+      <p:bgRef idx="1001">
+        <a:schemeClr val="bg1"/>
+      </p:bgRef>
+    </p:bg>
     <p:spTree>
       <p:nvGrpSpPr>
         <p:cNvPr id="1" name=""/>
@@ -1838,6 +1576,7 @@
         <a:solidFill>
           <a:srgbClr val="3D2EE8"/>
         </a:solidFill>
+        <a:effectLst/>
       </p:bgPr>
     </p:bg>
     <p:spTree>
@@ -1856,22 +1595,22 @@
       </p:grpSpPr>
       <p:pic>
         <p:nvPicPr>
-          <p:cNvPr id="2" name="Image 0" descr="/sessions/sleepy-zen-cray/mnt/outputs/deck_assets/logo_principal_blanco.png">    </p:cNvPr>
+          <p:cNvPr id="2" name="Image 0" descr="/sessions/sleepy-zen-cray/mnt/outputs/deck_assets/logo_principal_blanco.png"/>
           <p:cNvPicPr>
             <a:picLocks noChangeAspect="1"/>
           </p:cNvPicPr>
           <p:nvPr/>
         </p:nvPicPr>
         <p:blipFill>
-          <a:blip r:embed="rId1"/>
+          <a:blip r:embed="rId3"/>
           <a:stretch>
             <a:fillRect/>
           </a:stretch>
         </p:blipFill>
         <p:spPr>
           <a:xfrm>
-            <a:off x="5532120" y="365760"/>
-            <a:ext cx="1097280" cy="1097280"/>
+            <a:off x="4118956" y="-1001915"/>
+            <a:ext cx="3676535" cy="3676535"/>
           </a:xfrm>
           <a:prstGeom prst="rect">
             <a:avLst/>
@@ -1899,11 +1638,11 @@
           <a:bodyPr wrap="square" rtlCol="0" anchor="ctr"/>
           <a:lstStyle/>
           <a:p>
-            <a:pPr algn="ctr" indent="0" marL="0">
-              <a:buNone/>
-            </a:pPr>
-            <a:r>
-              <a:rPr lang="en-US" sz="1400" spc="800" kern="0" dirty="0">
+            <a:pPr marL="0" indent="0" algn="ctr">
+              <a:buNone/>
+            </a:pPr>
+            <a:r>
+              <a:rPr lang="en-US" sz="1400" kern="0" spc="800" dirty="0">
                 <a:solidFill>
                   <a:srgbClr val="FFFFFF"/>
                 </a:solidFill>
@@ -1938,7 +1677,7 @@
           <a:bodyPr wrap="square" rtlCol="0" anchor="ctr"/>
           <a:lstStyle/>
           <a:p>
-            <a:pPr algn="ctr" indent="0" marL="0">
+            <a:pPr marL="0" indent="0" algn="ctr">
               <a:buNone/>
             </a:pPr>
             <a:r>
@@ -1977,7 +1716,7 @@
           <a:bodyPr wrap="square" rtlCol="0" anchor="ctr"/>
           <a:lstStyle/>
           <a:p>
-            <a:pPr algn="ctr" indent="0" marL="0">
+            <a:pPr marL="0" indent="0" algn="ctr">
               <a:buNone/>
             </a:pPr>
             <a:r>
@@ -2016,7 +1755,7 @@
           <a:bodyPr wrap="square" rtlCol="0" anchor="ctr"/>
           <a:lstStyle/>
           <a:p>
-            <a:pPr algn="ctr" indent="0" marL="0">
+            <a:pPr marL="0" indent="0" algn="ctr">
               <a:buNone/>
             </a:pPr>
             <a:r>
@@ -2036,14 +1775,14 @@
       </p:sp>
       <p:pic>
         <p:nvPicPr>
-          <p:cNvPr id="7" name="Image 1" descr="/sessions/sleepy-zen-cray/mnt/outputs/deck_assets/sello_linea_v1_05.png">    </p:cNvPr>
+          <p:cNvPr id="7" name="Image 1" descr="/sessions/sleepy-zen-cray/mnt/outputs/deck_assets/sello_linea_v1_05.png"/>
           <p:cNvPicPr>
             <a:picLocks noChangeAspect="1"/>
           </p:cNvPicPr>
           <p:nvPr/>
         </p:nvPicPr>
         <p:blipFill>
-          <a:blip r:embed="rId2"/>
+          <a:blip r:embed="rId4"/>
           <a:stretch>
             <a:fillRect/>
           </a:stretch>
@@ -2079,11 +1818,11 @@
           <a:bodyPr wrap="square" rtlCol="0" anchor="ctr"/>
           <a:lstStyle/>
           <a:p>
-            <a:pPr algn="ctr" indent="0" marL="0">
-              <a:buNone/>
-            </a:pPr>
-            <a:r>
-              <a:rPr lang="en-US" sz="1000" spc="400" kern="0" dirty="0">
+            <a:pPr marL="0" indent="0" algn="ctr">
+              <a:buNone/>
+            </a:pPr>
+            <a:r>
+              <a:rPr lang="en-US" sz="1000" kern="0" spc="400" dirty="0">
                 <a:solidFill>
                   <a:srgbClr val="FFFFFF"/>
                 </a:solidFill>
@@ -2094,6 +1833,58 @@
               <a:t>Profesora · Jay Kim · 김재희</a:t>
             </a:r>
             <a:endParaRPr lang="en-US" sz="1000" dirty="0"/>
+          </a:p>
+        </p:txBody>
+      </p:sp>
+      <p:sp>
+        <p:nvSpPr>
+          <p:cNvPr id="9" name="TextBox 8">
+            <a:extLst>
+              <a:ext uri="{FF2B5EF4-FFF2-40B4-BE49-F238E27FC236}">
+                <a16:creationId xmlns:a16="http://schemas.microsoft.com/office/drawing/2014/main" id="{0F6A98DF-EBB4-ADEC-BD37-DA5A33A61930}"/>
+              </a:ext>
+            </a:extLst>
+          </p:cNvPr>
+          <p:cNvSpPr txBox="1"/>
+          <p:nvPr/>
+        </p:nvSpPr>
+        <p:spPr>
+          <a:xfrm>
+            <a:off x="9005455" y="1403927"/>
+            <a:ext cx="2051908" cy="369332"/>
+          </a:xfrm>
+          <a:prstGeom prst="rect">
+            <a:avLst/>
+          </a:prstGeom>
+          <a:noFill/>
+        </p:spPr>
+        <p:txBody>
+          <a:bodyPr wrap="none" rtlCol="0">
+            <a:spAutoFit/>
+          </a:bodyPr>
+          <a:lstStyle/>
+          <a:p>
+            <a:r>
+              <a:rPr lang="es-CL" altLang="ko-KR" dirty="0"/>
+              <a:t>‘ </a:t>
+            </a:r>
+            <a:r>
+              <a:rPr lang="ko-KR" altLang="es-CL" dirty="0"/>
+              <a:t>사다</a:t>
+            </a:r>
+            <a:r>
+              <a:rPr lang="es-CL" altLang="ko-KR" dirty="0"/>
+              <a:t>＇</a:t>
+            </a:r>
+            <a:r>
+              <a:rPr lang="ko-KR" altLang="es-CL" dirty="0"/>
+              <a:t> </a:t>
+            </a:r>
+            <a:r>
+              <a:rPr lang="es-CL" altLang="ko-KR" dirty="0"/>
+              <a:t>=  comprar</a:t>
+            </a:r>
+            <a:endParaRPr lang="es-CL" dirty="0"/>
           </a:p>
         </p:txBody>
       </p:sp>
@@ -2113,6 +1904,7 @@
         <a:solidFill>
           <a:srgbClr val="FFFFFF"/>
         </a:solidFill>
+        <a:effectLst/>
       </p:bgPr>
     </p:bg>
     <p:spTree>
@@ -2150,11 +1942,11 @@
           <a:bodyPr wrap="square" rtlCol="0" anchor="ctr"/>
           <a:lstStyle/>
           <a:p>
-            <a:pPr indent="0" marL="0">
-              <a:buNone/>
-            </a:pPr>
-            <a:r>
-              <a:rPr lang="en-US" sz="900" b="1" spc="600" kern="0" dirty="0">
+            <a:pPr marL="0" indent="0">
+              <a:buNone/>
+            </a:pPr>
+            <a:r>
+              <a:rPr lang="en-US" sz="900" b="1" kern="0" spc="600" dirty="0">
                 <a:solidFill>
                   <a:srgbClr val="3D2EE8"/>
                 </a:solidFill>
@@ -2189,7 +1981,7 @@
           <a:bodyPr wrap="square" rtlCol="0" anchor="ctr"/>
           <a:lstStyle/>
           <a:p>
-            <a:pPr indent="0" marL="0">
+            <a:pPr marL="0" indent="0">
               <a:buNone/>
             </a:pPr>
             <a:r>
@@ -2255,7 +2047,7 @@
           <a:bodyPr wrap="square" rtlCol="0" anchor="ctr"/>
           <a:lstStyle/>
           <a:p>
-            <a:pPr indent="0" marL="0">
+            <a:pPr marL="0" indent="0">
               <a:buNone/>
             </a:pPr>
             <a:r>
@@ -2294,7 +2086,7 @@
           <a:bodyPr wrap="square" rtlCol="0" anchor="ctr"/>
           <a:lstStyle/>
           <a:p>
-            <a:pPr indent="0" marL="0">
+            <a:pPr marL="0" indent="0">
               <a:buNone/>
             </a:pPr>
             <a:r>
@@ -2333,7 +2125,7 @@
           <a:bodyPr wrap="square" rtlCol="0" anchor="ctr"/>
           <a:lstStyle/>
           <a:p>
-            <a:pPr indent="0" marL="0">
+            <a:pPr marL="0" indent="0">
               <a:buNone/>
             </a:pPr>
             <a:r>
@@ -2372,7 +2164,7 @@
           <a:bodyPr wrap="square" rtlCol="0" anchor="ctr"/>
           <a:lstStyle/>
           <a:p>
-            <a:pPr indent="0" marL="0">
+            <a:pPr marL="0" indent="0">
               <a:buNone/>
             </a:pPr>
             <a:r>
@@ -2411,7 +2203,7 @@
           <a:bodyPr wrap="square" rtlCol="0" anchor="ctr"/>
           <a:lstStyle/>
           <a:p>
-            <a:pPr indent="0" marL="0">
+            <a:pPr marL="0" indent="0">
               <a:buNone/>
             </a:pPr>
             <a:r>
@@ -2450,7 +2242,7 @@
           <a:bodyPr wrap="square" rtlCol="0" anchor="ctr"/>
           <a:lstStyle/>
           <a:p>
-            <a:pPr indent="0" marL="0">
+            <a:pPr marL="0" indent="0">
               <a:buNone/>
             </a:pPr>
             <a:r>
@@ -2489,7 +2281,7 @@
           <a:bodyPr wrap="square" rtlCol="0" anchor="ctr"/>
           <a:lstStyle/>
           <a:p>
-            <a:pPr indent="0" marL="0">
+            <a:pPr marL="0" indent="0">
               <a:buNone/>
             </a:pPr>
             <a:r>
@@ -2528,7 +2320,7 @@
           <a:bodyPr wrap="square" rtlCol="0" anchor="ctr"/>
           <a:lstStyle/>
           <a:p>
-            <a:pPr indent="0" marL="0">
+            <a:pPr marL="0" indent="0">
               <a:buNone/>
             </a:pPr>
             <a:r>
@@ -2567,7 +2359,7 @@
           <a:bodyPr wrap="square" rtlCol="0" anchor="ctr"/>
           <a:lstStyle/>
           <a:p>
-            <a:pPr indent="0" marL="0">
+            <a:pPr marL="0" indent="0">
               <a:buNone/>
             </a:pPr>
             <a:r>
@@ -2606,7 +2398,7 @@
           <a:bodyPr wrap="square" rtlCol="0" anchor="ctr"/>
           <a:lstStyle/>
           <a:p>
-            <a:pPr indent="0" marL="0">
+            <a:pPr marL="0" indent="0">
               <a:buNone/>
             </a:pPr>
             <a:r>
@@ -2645,7 +2437,7 @@
           <a:bodyPr wrap="square" rtlCol="0" anchor="ctr"/>
           <a:lstStyle/>
           <a:p>
-            <a:pPr indent="0" marL="0">
+            <a:pPr marL="0" indent="0">
               <a:buNone/>
             </a:pPr>
             <a:r>
@@ -2684,7 +2476,7 @@
           <a:bodyPr wrap="square" rtlCol="0" anchor="ctr"/>
           <a:lstStyle/>
           <a:p>
-            <a:pPr indent="0" marL="0">
+            <a:pPr marL="0" indent="0">
               <a:buNone/>
             </a:pPr>
             <a:r>
@@ -2723,7 +2515,7 @@
           <a:bodyPr wrap="square" rtlCol="0" anchor="ctr"/>
           <a:lstStyle/>
           <a:p>
-            <a:pPr indent="0" marL="0">
+            <a:pPr marL="0" indent="0">
               <a:buNone/>
             </a:pPr>
             <a:r>
@@ -2762,7 +2554,7 @@
           <a:bodyPr wrap="square" rtlCol="0" anchor="ctr"/>
           <a:lstStyle/>
           <a:p>
-            <a:pPr indent="0" marL="0">
+            <a:pPr marL="0" indent="0">
               <a:buNone/>
             </a:pPr>
             <a:r>
@@ -2801,7 +2593,7 @@
           <a:bodyPr wrap="square" rtlCol="0" anchor="ctr"/>
           <a:lstStyle/>
           <a:p>
-            <a:pPr indent="0" marL="0">
+            <a:pPr marL="0" indent="0">
               <a:buNone/>
             </a:pPr>
             <a:r>
@@ -2840,7 +2632,7 @@
           <a:bodyPr wrap="square" rtlCol="0" anchor="ctr"/>
           <a:lstStyle/>
           <a:p>
-            <a:pPr indent="0" marL="0">
+            <a:pPr marL="0" indent="0">
               <a:buNone/>
             </a:pPr>
             <a:r>
@@ -2879,7 +2671,7 @@
           <a:bodyPr wrap="square" rtlCol="0" anchor="ctr"/>
           <a:lstStyle/>
           <a:p>
-            <a:pPr indent="0" marL="0">
+            <a:pPr marL="0" indent="0">
               <a:buNone/>
             </a:pPr>
             <a:r>
@@ -2918,7 +2710,7 @@
           <a:bodyPr wrap="square" rtlCol="0" anchor="ctr"/>
           <a:lstStyle/>
           <a:p>
-            <a:pPr indent="0" marL="0">
+            <a:pPr marL="0" indent="0">
               <a:buNone/>
             </a:pPr>
             <a:r>
@@ -2938,14 +2730,14 @@
       </p:sp>
       <p:pic>
         <p:nvPicPr>
-          <p:cNvPr id="23" name="Image 0" descr="/sessions/sleepy-zen-cray/mnt/outputs/deck_assets/logo_var2_azul.png">    </p:cNvPr>
+          <p:cNvPr id="23" name="Image 0" descr="/sessions/sleepy-zen-cray/mnt/outputs/deck_assets/logo_var2_azul.png"/>
           <p:cNvPicPr>
             <a:picLocks noChangeAspect="1"/>
           </p:cNvPicPr>
           <p:nvPr/>
         </p:nvPicPr>
         <p:blipFill>
-          <a:blip r:embed="rId1"/>
+          <a:blip r:embed="rId3"/>
           <a:stretch>
             <a:fillRect/>
           </a:stretch>
@@ -2962,14 +2754,14 @@
       </p:pic>
       <p:pic>
         <p:nvPicPr>
-          <p:cNvPr id="24" name="Image 1" descr="/sessions/sleepy-zen-cray/mnt/outputs/deck_assets/sello_linea_v1_01.png">    </p:cNvPr>
+          <p:cNvPr id="24" name="Image 1" descr="/sessions/sleepy-zen-cray/mnt/outputs/deck_assets/sello_linea_v1_01.png"/>
           <p:cNvPicPr>
             <a:picLocks noChangeAspect="1"/>
           </p:cNvPicPr>
           <p:nvPr/>
         </p:nvPicPr>
         <p:blipFill>
-          <a:blip r:embed="rId2"/>
+          <a:blip r:embed="rId4"/>
           <a:stretch>
             <a:fillRect/>
           </a:stretch>
@@ -3005,7 +2797,7 @@
           <a:bodyPr wrap="square" rtlCol="0" anchor="ctr"/>
           <a:lstStyle/>
           <a:p>
-            <a:pPr indent="0" marL="0">
+            <a:pPr marL="0" indent="0">
               <a:buNone/>
             </a:pPr>
             <a:r>
@@ -3044,7 +2836,7 @@
           <a:bodyPr wrap="square" rtlCol="0" anchor="ctr"/>
           <a:lstStyle/>
           <a:p>
-            <a:pPr algn="r" indent="0" marL="0">
+            <a:pPr marL="0" indent="0" algn="r">
               <a:buNone/>
             </a:pPr>
             <a:r>
@@ -3078,6 +2870,7 @@
         <a:solidFill>
           <a:srgbClr val="FF5C5C"/>
         </a:solidFill>
+        <a:effectLst/>
       </p:bgPr>
     </p:bg>
     <p:spTree>
@@ -3096,14 +2889,14 @@
       </p:grpSpPr>
       <p:pic>
         <p:nvPicPr>
-          <p:cNvPr id="2" name="Image 0" descr="/sessions/sleepy-zen-cray/mnt/outputs/deck_assets/logo_principal_blanco.png">    </p:cNvPr>
+          <p:cNvPr id="2" name="Image 0" descr="/sessions/sleepy-zen-cray/mnt/outputs/deck_assets/logo_principal_blanco.png"/>
           <p:cNvPicPr>
             <a:picLocks noChangeAspect="1"/>
           </p:cNvPicPr>
           <p:nvPr/>
         </p:nvPicPr>
         <p:blipFill>
-          <a:blip r:embed="rId1"/>
+          <a:blip r:embed="rId3"/>
           <a:stretch>
             <a:fillRect/>
           </a:stretch>
@@ -3139,11 +2932,11 @@
           <a:bodyPr wrap="square" rtlCol="0" anchor="ctr"/>
           <a:lstStyle/>
           <a:p>
-            <a:pPr algn="ctr" indent="0" marL="0">
-              <a:buNone/>
-            </a:pPr>
-            <a:r>
-              <a:rPr lang="en-US" sz="1000" b="1" spc="800" kern="0" dirty="0">
+            <a:pPr marL="0" indent="0" algn="ctr">
+              <a:buNone/>
+            </a:pPr>
+            <a:r>
+              <a:rPr lang="en-US" sz="1000" b="1" kern="0" spc="800" dirty="0">
                 <a:solidFill>
                   <a:srgbClr val="FFFFFF"/>
                 </a:solidFill>
@@ -3178,7 +2971,7 @@
           <a:bodyPr wrap="square" rtlCol="0" anchor="ctr"/>
           <a:lstStyle/>
           <a:p>
-            <a:pPr algn="ctr" indent="0" marL="0">
+            <a:pPr marL="0" indent="0" algn="ctr">
               <a:buNone/>
             </a:pPr>
             <a:r>
@@ -3244,7 +3037,7 @@
           <a:bodyPr wrap="square" rtlCol="0" anchor="t"/>
           <a:lstStyle/>
           <a:p>
-            <a:pPr indent="0" marL="0">
+            <a:pPr marL="0" indent="0">
               <a:lnSpc>
                 <a:spcPct val="150000"/>
               </a:lnSpc>
@@ -3264,7 +3057,7 @@
             <a:endParaRPr lang="en-US" sz="1500" dirty="0"/>
           </a:p>
           <a:p>
-            <a:pPr indent="0" marL="0">
+            <a:pPr marL="0" indent="0">
               <a:lnSpc>
                 <a:spcPct val="150000"/>
               </a:lnSpc>
@@ -3284,7 +3077,7 @@
             <a:endParaRPr lang="en-US" sz="1500" dirty="0"/>
           </a:p>
           <a:p>
-            <a:pPr indent="0" marL="0">
+            <a:pPr marL="0" indent="0">
               <a:lnSpc>
                 <a:spcPct val="150000"/>
               </a:lnSpc>
@@ -3304,7 +3097,7 @@
             <a:endParaRPr lang="en-US" sz="1500" dirty="0"/>
           </a:p>
           <a:p>
-            <a:pPr indent="0" marL="0">
+            <a:pPr marL="0" indent="0">
               <a:lnSpc>
                 <a:spcPct val="150000"/>
               </a:lnSpc>
@@ -3324,7 +3117,7 @@
             <a:endParaRPr lang="en-US" sz="1500" dirty="0"/>
           </a:p>
           <a:p>
-            <a:pPr indent="0" marL="0">
+            <a:pPr marL="0" indent="0">
               <a:lnSpc>
                 <a:spcPct val="150000"/>
               </a:lnSpc>
@@ -3344,7 +3137,7 @@
             <a:endParaRPr lang="en-US" sz="1500" dirty="0"/>
           </a:p>
           <a:p>
-            <a:pPr indent="0" marL="0">
+            <a:pPr marL="0" indent="0">
               <a:lnSpc>
                 <a:spcPct val="150000"/>
               </a:lnSpc>
@@ -3364,7 +3157,7 @@
             <a:endParaRPr lang="en-US" sz="1500" dirty="0"/>
           </a:p>
           <a:p>
-            <a:pPr indent="0" marL="0">
+            <a:pPr marL="0" indent="0">
               <a:lnSpc>
                 <a:spcPct val="150000"/>
               </a:lnSpc>
@@ -3406,11 +3199,11 @@
           <a:bodyPr wrap="square" rtlCol="0" anchor="ctr"/>
           <a:lstStyle/>
           <a:p>
-            <a:pPr algn="ctr" indent="0" marL="0">
-              <a:buNone/>
-            </a:pPr>
-            <a:r>
-              <a:rPr lang="en-US" sz="1200" b="1" spc="600" kern="0" dirty="0">
+            <a:pPr marL="0" indent="0" algn="ctr">
+              <a:buNone/>
+            </a:pPr>
+            <a:r>
+              <a:rPr lang="en-US" sz="1200" b="1" kern="0" spc="600" dirty="0">
                 <a:solidFill>
                   <a:srgbClr val="FFFFFF"/>
                 </a:solidFill>
@@ -3445,7 +3238,7 @@
           <a:bodyPr wrap="square" rtlCol="0" anchor="ctr"/>
           <a:lstStyle/>
           <a:p>
-            <a:pPr algn="ctr" indent="0" marL="0">
+            <a:pPr marL="0" indent="0" algn="ctr">
               <a:buNone/>
             </a:pPr>
             <a:r>
@@ -3479,6 +3272,7 @@
         <a:solidFill>
           <a:srgbClr val="3D2EE8"/>
         </a:solidFill>
+        <a:effectLst/>
       </p:bgPr>
     </p:bg>
     <p:spTree>
@@ -3516,7 +3310,7 @@
           <a:bodyPr wrap="square" rtlCol="0" anchor="ctr"/>
           <a:lstStyle/>
           <a:p>
-            <a:pPr algn="ctr" indent="0" marL="0">
+            <a:pPr marL="0" indent="0" algn="ctr">
               <a:buNone/>
             </a:pPr>
             <a:r>
@@ -3555,7 +3349,7 @@
           <a:bodyPr wrap="square" rtlCol="0" anchor="ctr"/>
           <a:lstStyle/>
           <a:p>
-            <a:pPr algn="ctr" indent="0" marL="0">
+            <a:pPr marL="0" indent="0" algn="ctr">
               <a:buNone/>
             </a:pPr>
             <a:r>
@@ -3575,14 +3369,14 @@
       </p:sp>
       <p:pic>
         <p:nvPicPr>
-          <p:cNvPr id="4" name="Image 0" descr="/sessions/sleepy-zen-cray/mnt/outputs/deck_assets/logo_principal_blanco.png">    </p:cNvPr>
+          <p:cNvPr id="4" name="Image 0" descr="/sessions/sleepy-zen-cray/mnt/outputs/deck_assets/logo_principal_blanco.png"/>
           <p:cNvPicPr>
             <a:picLocks noChangeAspect="1"/>
           </p:cNvPicPr>
           <p:nvPr/>
         </p:nvPicPr>
         <p:blipFill>
-          <a:blip r:embed="rId1"/>
+          <a:blip r:embed="rId3"/>
           <a:stretch>
             <a:fillRect/>
           </a:stretch>
@@ -3618,11 +3412,11 @@
           <a:bodyPr wrap="square" rtlCol="0" anchor="ctr"/>
           <a:lstStyle/>
           <a:p>
-            <a:pPr algn="ctr" indent="0" marL="0">
-              <a:buNone/>
-            </a:pPr>
-            <a:r>
-              <a:rPr lang="en-US" sz="1000" b="1" spc="600" kern="0" dirty="0">
+            <a:pPr marL="0" indent="0" algn="ctr">
+              <a:buNone/>
+            </a:pPr>
+            <a:r>
+              <a:rPr lang="en-US" sz="1000" b="1" kern="0" spc="600" dirty="0">
                 <a:solidFill>
                   <a:srgbClr val="FFFFFF"/>
                 </a:solidFill>
@@ -3652,6 +3446,7 @@
         <a:solidFill>
           <a:srgbClr val="FFFFFF"/>
         </a:solidFill>
+        <a:effectLst/>
       </p:bgPr>
     </p:bg>
     <p:spTree>
@@ -3689,11 +3484,11 @@
           <a:bodyPr wrap="square" rtlCol="0" anchor="ctr"/>
           <a:lstStyle/>
           <a:p>
-            <a:pPr indent="0" marL="0">
-              <a:buNone/>
-            </a:pPr>
-            <a:r>
-              <a:rPr lang="en-US" sz="900" b="1" spc="600" kern="0" dirty="0">
+            <a:pPr marL="0" indent="0">
+              <a:buNone/>
+            </a:pPr>
+            <a:r>
+              <a:rPr lang="en-US" sz="900" b="1" kern="0" spc="600" dirty="0">
                 <a:solidFill>
                   <a:srgbClr val="3D2EE8"/>
                 </a:solidFill>
@@ -3728,7 +3523,7 @@
           <a:bodyPr wrap="square" rtlCol="0" anchor="ctr"/>
           <a:lstStyle/>
           <a:p>
-            <a:pPr indent="0" marL="0">
+            <a:pPr marL="0" indent="0">
               <a:buNone/>
             </a:pPr>
             <a:r>
@@ -3767,7 +3562,7 @@
           <a:bodyPr wrap="square" rtlCol="0" anchor="t"/>
           <a:lstStyle/>
           <a:p>
-            <a:pPr indent="0" marL="0">
+            <a:pPr marL="0" indent="0">
               <a:lnSpc>
                 <a:spcPct val="140000"/>
               </a:lnSpc>
@@ -3787,7 +3582,7 @@
             <a:endParaRPr lang="en-US" sz="1600" dirty="0"/>
           </a:p>
           <a:p>
-            <a:pPr indent="0" marL="0">
+            <a:pPr marL="0" indent="0">
               <a:lnSpc>
                 <a:spcPct val="140000"/>
               </a:lnSpc>
@@ -3796,7 +3591,7 @@
             <a:endParaRPr lang="en-US" sz="1600" dirty="0"/>
           </a:p>
           <a:p>
-            <a:pPr indent="0" marL="0">
+            <a:pPr marL="0" indent="0">
               <a:lnSpc>
                 <a:spcPct val="140000"/>
               </a:lnSpc>
@@ -3811,12 +3606,34 @@
                 <a:ea typeface="Calibri" pitchFamily="34" charset="-122"/>
                 <a:cs typeface="Calibri" pitchFamily="34" charset="-120"/>
               </a:rPr>
-              <a:t>La frase MÁS útil del coreano que vas a aprender hoy: 주세요 (déme / por favor). La vas a decir miles de veces.</a:t>
+              <a:t>La frase MÁS útil del coreano que vas a aprender hoy: -</a:t>
+            </a:r>
+            <a:r>
+              <a:rPr lang="en-US" sz="1600" dirty="0" err="1">
+                <a:solidFill>
+                  <a:srgbClr val="1A1A2E"/>
+                </a:solidFill>
+                <a:latin typeface="Calibri" pitchFamily="34" charset="0"/>
+                <a:ea typeface="Calibri" pitchFamily="34" charset="-122"/>
+                <a:cs typeface="Calibri" pitchFamily="34" charset="-120"/>
+              </a:rPr>
+              <a:t>주세요</a:t>
+            </a:r>
+            <a:r>
+              <a:rPr lang="en-US" sz="1600" dirty="0">
+                <a:solidFill>
+                  <a:srgbClr val="1A1A2E"/>
+                </a:solidFill>
+                <a:latin typeface="Calibri" pitchFamily="34" charset="0"/>
+                <a:ea typeface="Calibri" pitchFamily="34" charset="-122"/>
+                <a:cs typeface="Calibri" pitchFamily="34" charset="-120"/>
+              </a:rPr>
+              <a:t> (déme / por favor). La vas a decir miles de veces.</a:t>
             </a:r>
             <a:endParaRPr lang="en-US" sz="1600" dirty="0"/>
           </a:p>
           <a:p>
-            <a:pPr indent="0" marL="0">
+            <a:pPr marL="0" indent="0">
               <a:lnSpc>
                 <a:spcPct val="140000"/>
               </a:lnSpc>
@@ -3825,7 +3642,7 @@
             <a:endParaRPr lang="en-US" sz="1600" dirty="0"/>
           </a:p>
           <a:p>
-            <a:pPr indent="0" marL="0">
+            <a:pPr marL="0" indent="0">
               <a:lnSpc>
                 <a:spcPct val="140000"/>
               </a:lnSpc>
@@ -3848,14 +3665,14 @@
       </p:sp>
       <p:pic>
         <p:nvPicPr>
-          <p:cNvPr id="5" name="Image 0" descr="/sessions/sleepy-zen-cray/mnt/outputs/deck_assets/sello_relleno_v1_01.png">    </p:cNvPr>
+          <p:cNvPr id="5" name="Image 0" descr="/sessions/sleepy-zen-cray/mnt/outputs/deck_assets/sello_relleno_v1_01.png"/>
           <p:cNvPicPr>
             <a:picLocks noChangeAspect="1"/>
           </p:cNvPicPr>
           <p:nvPr/>
         </p:nvPicPr>
         <p:blipFill>
-          <a:blip r:embed="rId1"/>
+          <a:blip r:embed="rId3"/>
           <a:stretch>
             <a:fillRect/>
           </a:stretch>
@@ -3872,14 +3689,14 @@
       </p:pic>
       <p:pic>
         <p:nvPicPr>
-          <p:cNvPr id="6" name="Image 1" descr="/sessions/sleepy-zen-cray/mnt/outputs/deck_assets/sello_linea_v1_01.png">    </p:cNvPr>
+          <p:cNvPr id="6" name="Image 1" descr="/sessions/sleepy-zen-cray/mnt/outputs/deck_assets/sello_linea_v1_01.png"/>
           <p:cNvPicPr>
             <a:picLocks noChangeAspect="1"/>
           </p:cNvPicPr>
           <p:nvPr/>
         </p:nvPicPr>
         <p:blipFill>
-          <a:blip r:embed="rId2"/>
+          <a:blip r:embed="rId4"/>
           <a:stretch>
             <a:fillRect/>
           </a:stretch>
@@ -3915,7 +3732,7 @@
           <a:bodyPr wrap="square" rtlCol="0" anchor="ctr"/>
           <a:lstStyle/>
           <a:p>
-            <a:pPr indent="0" marL="0">
+            <a:pPr marL="0" indent="0">
               <a:buNone/>
             </a:pPr>
             <a:r>
@@ -3954,7 +3771,7 @@
           <a:bodyPr wrap="square" rtlCol="0" anchor="ctr"/>
           <a:lstStyle/>
           <a:p>
-            <a:pPr algn="r" indent="0" marL="0">
+            <a:pPr marL="0" indent="0" algn="r">
               <a:buNone/>
             </a:pPr>
             <a:r>
@@ -3988,6 +3805,7 @@
         <a:solidFill>
           <a:srgbClr val="FFFFFF"/>
         </a:solidFill>
+        <a:effectLst/>
       </p:bgPr>
     </p:bg>
     <p:spTree>
@@ -4025,11 +3843,11 @@
           <a:bodyPr wrap="square" rtlCol="0" anchor="ctr"/>
           <a:lstStyle/>
           <a:p>
-            <a:pPr indent="0" marL="0">
-              <a:buNone/>
-            </a:pPr>
-            <a:r>
-              <a:rPr lang="en-US" sz="900" b="1" spc="600" kern="0" dirty="0">
+            <a:pPr marL="0" indent="0">
+              <a:buNone/>
+            </a:pPr>
+            <a:r>
+              <a:rPr lang="en-US" sz="900" b="1" kern="0" spc="600" dirty="0">
                 <a:solidFill>
                   <a:srgbClr val="3D2EE8"/>
                 </a:solidFill>
@@ -4064,7 +3882,7 @@
           <a:bodyPr wrap="square" rtlCol="0" anchor="ctr"/>
           <a:lstStyle/>
           <a:p>
-            <a:pPr indent="0" marL="0">
+            <a:pPr marL="0" indent="0">
               <a:buNone/>
             </a:pPr>
             <a:r>
@@ -4103,7 +3921,7 @@
           <a:bodyPr wrap="square" rtlCol="0" anchor="t"/>
           <a:lstStyle/>
           <a:p>
-            <a:pPr indent="0" marL="0">
+            <a:pPr marL="0" indent="0">
               <a:lnSpc>
                 <a:spcPct val="140000"/>
               </a:lnSpc>
@@ -4123,7 +3941,7 @@
             <a:endParaRPr lang="en-US" sz="1400" dirty="0"/>
           </a:p>
           <a:p>
-            <a:pPr indent="0" marL="0">
+            <a:pPr marL="0" indent="0">
               <a:lnSpc>
                 <a:spcPct val="140000"/>
               </a:lnSpc>
@@ -4132,7 +3950,7 @@
             <a:endParaRPr lang="en-US" sz="1400" dirty="0"/>
           </a:p>
           <a:p>
-            <a:pPr indent="0" marL="0">
+            <a:pPr marL="0" indent="0">
               <a:lnSpc>
                 <a:spcPct val="140000"/>
               </a:lnSpc>
@@ -4152,7 +3970,7 @@
             <a:endParaRPr lang="en-US" sz="1400" dirty="0"/>
           </a:p>
           <a:p>
-            <a:pPr indent="0" marL="0">
+            <a:pPr marL="0" indent="0">
               <a:lnSpc>
                 <a:spcPct val="140000"/>
               </a:lnSpc>
@@ -4172,7 +3990,7 @@
             <a:endParaRPr lang="en-US" sz="1400" dirty="0"/>
           </a:p>
           <a:p>
-            <a:pPr indent="0" marL="0">
+            <a:pPr marL="0" indent="0">
               <a:lnSpc>
                 <a:spcPct val="140000"/>
               </a:lnSpc>
@@ -4192,7 +4010,7 @@
             <a:endParaRPr lang="en-US" sz="1400" dirty="0"/>
           </a:p>
           <a:p>
-            <a:pPr indent="0" marL="0">
+            <a:pPr marL="0" indent="0">
               <a:lnSpc>
                 <a:spcPct val="140000"/>
               </a:lnSpc>
@@ -4201,7 +4019,7 @@
             <a:endParaRPr lang="en-US" sz="1400" dirty="0"/>
           </a:p>
           <a:p>
-            <a:pPr indent="0" marL="0">
+            <a:pPr marL="0" indent="0">
               <a:lnSpc>
                 <a:spcPct val="140000"/>
               </a:lnSpc>
@@ -4221,7 +4039,7 @@
             <a:endParaRPr lang="en-US" sz="1400" dirty="0"/>
           </a:p>
           <a:p>
-            <a:pPr indent="0" marL="0">
+            <a:pPr marL="0" indent="0">
               <a:lnSpc>
                 <a:spcPct val="140000"/>
               </a:lnSpc>
@@ -4230,7 +4048,7 @@
             <a:endParaRPr lang="en-US" sz="1400" dirty="0"/>
           </a:p>
           <a:p>
-            <a:pPr indent="0" marL="0">
+            <a:pPr marL="0" indent="0">
               <a:lnSpc>
                 <a:spcPct val="140000"/>
               </a:lnSpc>
@@ -4299,7 +4117,7 @@
           <a:bodyPr wrap="square" rtlCol="0" anchor="ctr"/>
           <a:lstStyle/>
           <a:p>
-            <a:pPr algn="ctr" indent="0" marL="0">
+            <a:pPr marL="0" indent="0" algn="ctr">
               <a:buNone/>
             </a:pPr>
             <a:r>
@@ -4338,7 +4156,7 @@
           <a:bodyPr wrap="square" rtlCol="0" anchor="ctr"/>
           <a:lstStyle/>
           <a:p>
-            <a:pPr algn="ctr" indent="0" marL="0">
+            <a:pPr marL="0" indent="0" algn="ctr">
               <a:buNone/>
             </a:pPr>
             <a:r>
@@ -4377,7 +4195,7 @@
           <a:bodyPr wrap="square" rtlCol="0" anchor="ctr"/>
           <a:lstStyle/>
           <a:p>
-            <a:pPr algn="ctr" indent="0" marL="0">
+            <a:pPr marL="0" indent="0" algn="ctr">
               <a:buNone/>
             </a:pPr>
             <a:r>
@@ -4397,14 +4215,14 @@
       </p:sp>
       <p:pic>
         <p:nvPicPr>
-          <p:cNvPr id="9" name="Image 0" descr="/sessions/sleepy-zen-cray/mnt/outputs/deck_assets/logo_var2_azul.png">    </p:cNvPr>
+          <p:cNvPr id="9" name="Image 0" descr="/sessions/sleepy-zen-cray/mnt/outputs/deck_assets/logo_var2_azul.png"/>
           <p:cNvPicPr>
             <a:picLocks noChangeAspect="1"/>
           </p:cNvPicPr>
           <p:nvPr/>
         </p:nvPicPr>
         <p:blipFill>
-          <a:blip r:embed="rId1"/>
+          <a:blip r:embed="rId3"/>
           <a:stretch>
             <a:fillRect/>
           </a:stretch>
@@ -4421,14 +4239,14 @@
       </p:pic>
       <p:pic>
         <p:nvPicPr>
-          <p:cNvPr id="10" name="Image 1" descr="/sessions/sleepy-zen-cray/mnt/outputs/deck_assets/sello_linea_v1_01.png">    </p:cNvPr>
+          <p:cNvPr id="10" name="Image 1" descr="/sessions/sleepy-zen-cray/mnt/outputs/deck_assets/sello_linea_v1_01.png"/>
           <p:cNvPicPr>
             <a:picLocks noChangeAspect="1"/>
           </p:cNvPicPr>
           <p:nvPr/>
         </p:nvPicPr>
         <p:blipFill>
-          <a:blip r:embed="rId2"/>
+          <a:blip r:embed="rId4"/>
           <a:stretch>
             <a:fillRect/>
           </a:stretch>
@@ -4464,7 +4282,7 @@
           <a:bodyPr wrap="square" rtlCol="0" anchor="ctr"/>
           <a:lstStyle/>
           <a:p>
-            <a:pPr indent="0" marL="0">
+            <a:pPr marL="0" indent="0">
               <a:buNone/>
             </a:pPr>
             <a:r>
@@ -4503,7 +4321,7 @@
           <a:bodyPr wrap="square" rtlCol="0" anchor="ctr"/>
           <a:lstStyle/>
           <a:p>
-            <a:pPr algn="r" indent="0" marL="0">
+            <a:pPr marL="0" indent="0" algn="r">
               <a:buNone/>
             </a:pPr>
             <a:r>
@@ -4537,6 +4355,7 @@
         <a:solidFill>
           <a:srgbClr val="FFFFFF"/>
         </a:solidFill>
+        <a:effectLst/>
       </p:bgPr>
     </p:bg>
     <p:spTree>
@@ -4574,11 +4393,11 @@
           <a:bodyPr wrap="square" rtlCol="0" anchor="ctr"/>
           <a:lstStyle/>
           <a:p>
-            <a:pPr indent="0" marL="0">
-              <a:buNone/>
-            </a:pPr>
-            <a:r>
-              <a:rPr lang="en-US" sz="900" b="1" spc="600" kern="0" dirty="0">
+            <a:pPr marL="0" indent="0">
+              <a:buNone/>
+            </a:pPr>
+            <a:r>
+              <a:rPr lang="en-US" sz="900" b="1" kern="0" spc="600" dirty="0">
                 <a:solidFill>
                   <a:srgbClr val="3D2EE8"/>
                 </a:solidFill>
@@ -4613,7 +4432,7 @@
           <a:bodyPr wrap="square" rtlCol="0" anchor="ctr"/>
           <a:lstStyle/>
           <a:p>
-            <a:pPr indent="0" marL="0">
+            <a:pPr marL="0" indent="0">
               <a:buNone/>
             </a:pPr>
             <a:r>
@@ -4679,7 +4498,7 @@
           <a:bodyPr wrap="square" rtlCol="0" anchor="ctr"/>
           <a:lstStyle/>
           <a:p>
-            <a:pPr algn="ctr" indent="0" marL="0">
+            <a:pPr marL="0" indent="0" algn="ctr">
               <a:buNone/>
             </a:pPr>
             <a:r>
@@ -4718,7 +4537,7 @@
           <a:bodyPr wrap="square" rtlCol="0" anchor="ctr"/>
           <a:lstStyle/>
           <a:p>
-            <a:pPr algn="ctr" indent="0" marL="0">
+            <a:pPr marL="0" indent="0" algn="ctr">
               <a:buNone/>
             </a:pPr>
             <a:r>
@@ -4784,7 +4603,7 @@
           <a:bodyPr wrap="square" rtlCol="0" anchor="ctr"/>
           <a:lstStyle/>
           <a:p>
-            <a:pPr algn="ctr" indent="0" marL="0">
+            <a:pPr marL="0" indent="0" algn="ctr">
               <a:buNone/>
             </a:pPr>
             <a:r>
@@ -4823,7 +4642,7 @@
           <a:bodyPr wrap="square" rtlCol="0" anchor="ctr"/>
           <a:lstStyle/>
           <a:p>
-            <a:pPr algn="ctr" indent="0" marL="0">
+            <a:pPr marL="0" indent="0" algn="ctr">
               <a:buNone/>
             </a:pPr>
             <a:r>
@@ -4889,7 +4708,7 @@
           <a:bodyPr wrap="square" rtlCol="0" anchor="ctr"/>
           <a:lstStyle/>
           <a:p>
-            <a:pPr algn="ctr" indent="0" marL="0">
+            <a:pPr marL="0" indent="0" algn="ctr">
               <a:buNone/>
             </a:pPr>
             <a:r>
@@ -4928,7 +4747,7 @@
           <a:bodyPr wrap="square" rtlCol="0" anchor="ctr"/>
           <a:lstStyle/>
           <a:p>
-            <a:pPr algn="ctr" indent="0" marL="0">
+            <a:pPr marL="0" indent="0" algn="ctr">
               <a:buNone/>
             </a:pPr>
             <a:r>
@@ -4994,7 +4813,7 @@
           <a:bodyPr wrap="square" rtlCol="0" anchor="ctr"/>
           <a:lstStyle/>
           <a:p>
-            <a:pPr algn="ctr" indent="0" marL="0">
+            <a:pPr marL="0" indent="0" algn="ctr">
               <a:buNone/>
             </a:pPr>
             <a:r>
@@ -5033,7 +4852,7 @@
           <a:bodyPr wrap="square" rtlCol="0" anchor="ctr"/>
           <a:lstStyle/>
           <a:p>
-            <a:pPr algn="ctr" indent="0" marL="0">
+            <a:pPr marL="0" indent="0" algn="ctr">
               <a:buNone/>
             </a:pPr>
             <a:r>
@@ -5099,7 +4918,7 @@
           <a:bodyPr wrap="square" rtlCol="0" anchor="ctr"/>
           <a:lstStyle/>
           <a:p>
-            <a:pPr algn="ctr" indent="0" marL="0">
+            <a:pPr marL="0" indent="0" algn="ctr">
               <a:buNone/>
             </a:pPr>
             <a:r>
@@ -5138,7 +4957,7 @@
           <a:bodyPr wrap="square" rtlCol="0" anchor="ctr"/>
           <a:lstStyle/>
           <a:p>
-            <a:pPr algn="ctr" indent="0" marL="0">
+            <a:pPr marL="0" indent="0" algn="ctr">
               <a:buNone/>
             </a:pPr>
             <a:r>
@@ -5204,7 +5023,7 @@
           <a:bodyPr wrap="square" rtlCol="0" anchor="ctr"/>
           <a:lstStyle/>
           <a:p>
-            <a:pPr algn="ctr" indent="0" marL="0">
+            <a:pPr marL="0" indent="0" algn="ctr">
               <a:buNone/>
             </a:pPr>
             <a:r>
@@ -5243,7 +5062,7 @@
           <a:bodyPr wrap="square" rtlCol="0" anchor="ctr"/>
           <a:lstStyle/>
           <a:p>
-            <a:pPr algn="ctr" indent="0" marL="0">
+            <a:pPr marL="0" indent="0" algn="ctr">
               <a:buNone/>
             </a:pPr>
             <a:r>
@@ -5309,7 +5128,7 @@
           <a:bodyPr wrap="square" rtlCol="0" anchor="ctr"/>
           <a:lstStyle/>
           <a:p>
-            <a:pPr algn="ctr" indent="0" marL="0">
+            <a:pPr marL="0" indent="0" algn="ctr">
               <a:buNone/>
             </a:pPr>
             <a:r>
@@ -5348,7 +5167,7 @@
           <a:bodyPr wrap="square" rtlCol="0" anchor="ctr"/>
           <a:lstStyle/>
           <a:p>
-            <a:pPr algn="ctr" indent="0" marL="0">
+            <a:pPr marL="0" indent="0" algn="ctr">
               <a:buNone/>
             </a:pPr>
             <a:r>
@@ -5414,7 +5233,7 @@
           <a:bodyPr wrap="square" rtlCol="0" anchor="ctr"/>
           <a:lstStyle/>
           <a:p>
-            <a:pPr algn="ctr" indent="0" marL="0">
+            <a:pPr marL="0" indent="0" algn="ctr">
               <a:buNone/>
             </a:pPr>
             <a:r>
@@ -5453,9 +5272,20 @@
           <a:bodyPr wrap="square" rtlCol="0" anchor="ctr"/>
           <a:lstStyle/>
           <a:p>
-            <a:pPr algn="ctr" indent="0" marL="0">
-              <a:buNone/>
-            </a:pPr>
+            <a:pPr marL="0" indent="0" algn="ctr">
+              <a:buNone/>
+            </a:pPr>
+            <a:r>
+              <a:rPr lang="en-US" sz="1200" dirty="0" err="1">
+                <a:solidFill>
+                  <a:srgbClr val="1A1A2E"/>
+                </a:solidFill>
+                <a:latin typeface="Calibri" pitchFamily="34" charset="0"/>
+                <a:ea typeface="Calibri" pitchFamily="34" charset="-122"/>
+                <a:cs typeface="Calibri" pitchFamily="34" charset="-120"/>
+              </a:rPr>
+              <a:t>Veces</a:t>
+            </a:r>
             <a:r>
               <a:rPr lang="en-US" sz="1200" dirty="0">
                 <a:solidFill>
@@ -5465,7 +5295,18 @@
                 <a:ea typeface="Calibri" pitchFamily="34" charset="-122"/>
                 <a:cs typeface="Calibri" pitchFamily="34" charset="-120"/>
               </a:rPr>
-              <a:t>veces</a:t>
+              <a:t> / </a:t>
+            </a:r>
+            <a:r>
+              <a:rPr lang="en-US" sz="1200" dirty="0" err="1">
+                <a:solidFill>
+                  <a:srgbClr val="1A1A2E"/>
+                </a:solidFill>
+                <a:latin typeface="Calibri" pitchFamily="34" charset="0"/>
+                <a:ea typeface="Calibri" pitchFamily="34" charset="-122"/>
+                <a:cs typeface="Calibri" pitchFamily="34" charset="-120"/>
+              </a:rPr>
+              <a:t>numero</a:t>
             </a:r>
             <a:endParaRPr lang="en-US" sz="1200" dirty="0"/>
           </a:p>
@@ -5473,14 +5314,14 @@
       </p:sp>
       <p:pic>
         <p:nvPicPr>
-          <p:cNvPr id="28" name="Image 0" descr="/sessions/sleepy-zen-cray/mnt/outputs/deck_assets/logo_var2_azul.png">    </p:cNvPr>
+          <p:cNvPr id="28" name="Image 0" descr="/sessions/sleepy-zen-cray/mnt/outputs/deck_assets/logo_var2_azul.png"/>
           <p:cNvPicPr>
             <a:picLocks noChangeAspect="1"/>
           </p:cNvPicPr>
           <p:nvPr/>
         </p:nvPicPr>
         <p:blipFill>
-          <a:blip r:embed="rId1"/>
+          <a:blip r:embed="rId3"/>
           <a:stretch>
             <a:fillRect/>
           </a:stretch>
@@ -5497,14 +5338,14 @@
       </p:pic>
       <p:pic>
         <p:nvPicPr>
-          <p:cNvPr id="29" name="Image 1" descr="/sessions/sleepy-zen-cray/mnt/outputs/deck_assets/sello_linea_v1_01.png">    </p:cNvPr>
+          <p:cNvPr id="29" name="Image 1" descr="/sessions/sleepy-zen-cray/mnt/outputs/deck_assets/sello_linea_v1_01.png"/>
           <p:cNvPicPr>
             <a:picLocks noChangeAspect="1"/>
           </p:cNvPicPr>
           <p:nvPr/>
         </p:nvPicPr>
         <p:blipFill>
-          <a:blip r:embed="rId2"/>
+          <a:blip r:embed="rId4"/>
           <a:stretch>
             <a:fillRect/>
           </a:stretch>
@@ -5540,7 +5381,7 @@
           <a:bodyPr wrap="square" rtlCol="0" anchor="ctr"/>
           <a:lstStyle/>
           <a:p>
-            <a:pPr indent="0" marL="0">
+            <a:pPr marL="0" indent="0">
               <a:buNone/>
             </a:pPr>
             <a:r>
@@ -5579,7 +5420,7 @@
           <a:bodyPr wrap="square" rtlCol="0" anchor="ctr"/>
           <a:lstStyle/>
           <a:p>
-            <a:pPr algn="r" indent="0" marL="0">
+            <a:pPr marL="0" indent="0" algn="r">
               <a:buNone/>
             </a:pPr>
             <a:r>
@@ -5613,6 +5454,7 @@
         <a:solidFill>
           <a:srgbClr val="FFFFFF"/>
         </a:solidFill>
+        <a:effectLst/>
       </p:bgPr>
     </p:bg>
     <p:spTree>
@@ -5650,11 +5492,11 @@
           <a:bodyPr wrap="square" rtlCol="0" anchor="ctr"/>
           <a:lstStyle/>
           <a:p>
-            <a:pPr indent="0" marL="0">
-              <a:buNone/>
-            </a:pPr>
-            <a:r>
-              <a:rPr lang="en-US" sz="900" b="1" spc="600" kern="0" dirty="0">
+            <a:pPr marL="0" indent="0">
+              <a:buNone/>
+            </a:pPr>
+            <a:r>
+              <a:rPr lang="en-US" sz="900" b="1" kern="0" spc="600" dirty="0">
                 <a:solidFill>
                   <a:srgbClr val="FF5C5C"/>
                 </a:solidFill>
@@ -5689,7 +5531,7 @@
           <a:bodyPr wrap="square" rtlCol="0" anchor="ctr"/>
           <a:lstStyle/>
           <a:p>
-            <a:pPr indent="0" marL="0">
+            <a:pPr marL="0" indent="0">
               <a:buNone/>
             </a:pPr>
             <a:r>
@@ -5755,7 +5597,7 @@
           <a:bodyPr wrap="square" rtlCol="0" anchor="ctr"/>
           <a:lstStyle/>
           <a:p>
-            <a:pPr algn="ctr" indent="0" marL="0">
+            <a:pPr marL="0" indent="0" algn="ctr">
               <a:buNone/>
             </a:pPr>
             <a:r>
@@ -5794,7 +5636,7 @@
           <a:bodyPr wrap="square" rtlCol="0" anchor="ctr"/>
           <a:lstStyle/>
           <a:p>
-            <a:pPr algn="ctr" indent="0" marL="0">
+            <a:pPr marL="0" indent="0" algn="ctr">
               <a:buNone/>
             </a:pPr>
             <a:r>
@@ -5860,7 +5702,7 @@
           <a:bodyPr wrap="square" rtlCol="0" anchor="ctr"/>
           <a:lstStyle/>
           <a:p>
-            <a:pPr algn="ctr" indent="0" marL="0">
+            <a:pPr marL="0" indent="0" algn="ctr">
               <a:buNone/>
             </a:pPr>
             <a:r>
@@ -5899,7 +5741,7 @@
           <a:bodyPr wrap="square" rtlCol="0" anchor="ctr"/>
           <a:lstStyle/>
           <a:p>
-            <a:pPr algn="ctr" indent="0" marL="0">
+            <a:pPr marL="0" indent="0" algn="ctr">
               <a:buNone/>
             </a:pPr>
             <a:r>
@@ -5965,7 +5807,7 @@
           <a:bodyPr wrap="square" rtlCol="0" anchor="ctr"/>
           <a:lstStyle/>
           <a:p>
-            <a:pPr algn="ctr" indent="0" marL="0">
+            <a:pPr marL="0" indent="0" algn="ctr">
               <a:buNone/>
             </a:pPr>
             <a:r>
@@ -6004,7 +5846,7 @@
           <a:bodyPr wrap="square" rtlCol="0" anchor="ctr"/>
           <a:lstStyle/>
           <a:p>
-            <a:pPr algn="ctr" indent="0" marL="0">
+            <a:pPr marL="0" indent="0" algn="ctr">
               <a:buNone/>
             </a:pPr>
             <a:r>
@@ -6070,7 +5912,7 @@
           <a:bodyPr wrap="square" rtlCol="0" anchor="ctr"/>
           <a:lstStyle/>
           <a:p>
-            <a:pPr algn="ctr" indent="0" marL="0">
+            <a:pPr marL="0" indent="0" algn="ctr">
               <a:buNone/>
             </a:pPr>
             <a:r>
@@ -6109,7 +5951,7 @@
           <a:bodyPr wrap="square" rtlCol="0" anchor="ctr"/>
           <a:lstStyle/>
           <a:p>
-            <a:pPr algn="ctr" indent="0" marL="0">
+            <a:pPr marL="0" indent="0" algn="ctr">
               <a:buNone/>
             </a:pPr>
             <a:r>
@@ -6175,7 +6017,7 @@
           <a:bodyPr wrap="square" rtlCol="0" anchor="ctr"/>
           <a:lstStyle/>
           <a:p>
-            <a:pPr algn="ctr" indent="0" marL="0">
+            <a:pPr marL="0" indent="0" algn="ctr">
               <a:buNone/>
             </a:pPr>
             <a:r>
@@ -6214,7 +6056,7 @@
           <a:bodyPr wrap="square" rtlCol="0" anchor="ctr"/>
           <a:lstStyle/>
           <a:p>
-            <a:pPr algn="ctr" indent="0" marL="0">
+            <a:pPr marL="0" indent="0" algn="ctr">
               <a:buNone/>
             </a:pPr>
             <a:r>
@@ -6280,7 +6122,7 @@
           <a:bodyPr wrap="square" rtlCol="0" anchor="ctr"/>
           <a:lstStyle/>
           <a:p>
-            <a:pPr algn="ctr" indent="0" marL="0">
+            <a:pPr marL="0" indent="0" algn="ctr">
               <a:buNone/>
             </a:pPr>
             <a:r>
@@ -6319,7 +6161,7 @@
           <a:bodyPr wrap="square" rtlCol="0" anchor="ctr"/>
           <a:lstStyle/>
           <a:p>
-            <a:pPr algn="ctr" indent="0" marL="0">
+            <a:pPr marL="0" indent="0" algn="ctr">
               <a:buNone/>
             </a:pPr>
             <a:r>
@@ -6339,14 +6181,14 @@
       </p:sp>
       <p:pic>
         <p:nvPicPr>
-          <p:cNvPr id="22" name="Image 0" descr="/sessions/sleepy-zen-cray/mnt/outputs/deck_assets/logo_var2_azul.png">    </p:cNvPr>
+          <p:cNvPr id="22" name="Image 0" descr="/sessions/sleepy-zen-cray/mnt/outputs/deck_assets/logo_var2_azul.png"/>
           <p:cNvPicPr>
             <a:picLocks noChangeAspect="1"/>
           </p:cNvPicPr>
           <p:nvPr/>
         </p:nvPicPr>
         <p:blipFill>
-          <a:blip r:embed="rId1"/>
+          <a:blip r:embed="rId3"/>
           <a:stretch>
             <a:fillRect/>
           </a:stretch>
@@ -6363,14 +6205,14 @@
       </p:pic>
       <p:pic>
         <p:nvPicPr>
-          <p:cNvPr id="23" name="Image 1" descr="/sessions/sleepy-zen-cray/mnt/outputs/deck_assets/sello_linea_v1_01.png">    </p:cNvPr>
+          <p:cNvPr id="23" name="Image 1" descr="/sessions/sleepy-zen-cray/mnt/outputs/deck_assets/sello_linea_v1_01.png"/>
           <p:cNvPicPr>
             <a:picLocks noChangeAspect="1"/>
           </p:cNvPicPr>
           <p:nvPr/>
         </p:nvPicPr>
         <p:blipFill>
-          <a:blip r:embed="rId2"/>
+          <a:blip r:embed="rId4"/>
           <a:stretch>
             <a:fillRect/>
           </a:stretch>
@@ -6406,7 +6248,7 @@
           <a:bodyPr wrap="square" rtlCol="0" anchor="ctr"/>
           <a:lstStyle/>
           <a:p>
-            <a:pPr indent="0" marL="0">
+            <a:pPr marL="0" indent="0">
               <a:buNone/>
             </a:pPr>
             <a:r>
@@ -6445,7 +6287,7 @@
           <a:bodyPr wrap="square" rtlCol="0" anchor="ctr"/>
           <a:lstStyle/>
           <a:p>
-            <a:pPr algn="r" indent="0" marL="0">
+            <a:pPr marL="0" indent="0" algn="r">
               <a:buNone/>
             </a:pPr>
             <a:r>
@@ -6479,6 +6321,7 @@
         <a:solidFill>
           <a:srgbClr val="FFFFFF"/>
         </a:solidFill>
+        <a:effectLst/>
       </p:bgPr>
     </p:bg>
     <p:spTree>
@@ -6516,11 +6359,11 @@
           <a:bodyPr wrap="square" rtlCol="0" anchor="ctr"/>
           <a:lstStyle/>
           <a:p>
-            <a:pPr indent="0" marL="0">
-              <a:buNone/>
-            </a:pPr>
-            <a:r>
-              <a:rPr lang="en-US" sz="900" b="1" spc="600" kern="0" dirty="0">
+            <a:pPr marL="0" indent="0">
+              <a:buNone/>
+            </a:pPr>
+            <a:r>
+              <a:rPr lang="en-US" sz="900" b="1" kern="0" spc="600" dirty="0">
                 <a:solidFill>
                   <a:srgbClr val="3D2EE8"/>
                 </a:solidFill>
@@ -6555,7 +6398,7 @@
           <a:bodyPr wrap="square" rtlCol="0" anchor="ctr"/>
           <a:lstStyle/>
           <a:p>
-            <a:pPr indent="0" marL="0">
+            <a:pPr marL="0" indent="0">
               <a:buNone/>
             </a:pPr>
             <a:r>
@@ -6594,7 +6437,7 @@
           <a:bodyPr wrap="square" rtlCol="0" anchor="t"/>
           <a:lstStyle/>
           <a:p>
-            <a:pPr indent="0" marL="0">
+            <a:pPr marL="0" indent="0">
               <a:lnSpc>
                 <a:spcPct val="140000"/>
               </a:lnSpc>
@@ -6614,7 +6457,7 @@
             <a:endParaRPr lang="en-US" sz="1400" dirty="0"/>
           </a:p>
           <a:p>
-            <a:pPr indent="0" marL="0">
+            <a:pPr marL="0" indent="0">
               <a:lnSpc>
                 <a:spcPct val="140000"/>
               </a:lnSpc>
@@ -6623,7 +6466,7 @@
             <a:endParaRPr lang="en-US" sz="1400" dirty="0"/>
           </a:p>
           <a:p>
-            <a:pPr indent="0" marL="0">
+            <a:pPr marL="0" indent="0">
               <a:lnSpc>
                 <a:spcPct val="140000"/>
               </a:lnSpc>
@@ -6643,7 +6486,7 @@
             <a:endParaRPr lang="en-US" sz="1400" dirty="0"/>
           </a:p>
           <a:p>
-            <a:pPr indent="0" marL="0">
+            <a:pPr marL="0" indent="0">
               <a:lnSpc>
                 <a:spcPct val="140000"/>
               </a:lnSpc>
@@ -6663,7 +6506,7 @@
             <a:endParaRPr lang="en-US" sz="1400" dirty="0"/>
           </a:p>
           <a:p>
-            <a:pPr indent="0" marL="0">
+            <a:pPr marL="0" indent="0">
               <a:lnSpc>
                 <a:spcPct val="140000"/>
               </a:lnSpc>
@@ -6683,7 +6526,7 @@
             <a:endParaRPr lang="en-US" sz="1400" dirty="0"/>
           </a:p>
           <a:p>
-            <a:pPr indent="0" marL="0">
+            <a:pPr marL="0" indent="0">
               <a:lnSpc>
                 <a:spcPct val="140000"/>
               </a:lnSpc>
@@ -6692,7 +6535,7 @@
             <a:endParaRPr lang="en-US" sz="1400" dirty="0"/>
           </a:p>
           <a:p>
-            <a:pPr indent="0" marL="0">
+            <a:pPr marL="0" indent="0">
               <a:lnSpc>
                 <a:spcPct val="140000"/>
               </a:lnSpc>
@@ -6712,7 +6555,7 @@
             <a:endParaRPr lang="en-US" sz="1400" dirty="0"/>
           </a:p>
           <a:p>
-            <a:pPr indent="0" marL="0">
+            <a:pPr marL="0" indent="0">
               <a:lnSpc>
                 <a:spcPct val="140000"/>
               </a:lnSpc>
@@ -6732,7 +6575,7 @@
             <a:endParaRPr lang="en-US" sz="1400" dirty="0"/>
           </a:p>
           <a:p>
-            <a:pPr indent="0" marL="0">
+            <a:pPr marL="0" indent="0">
               <a:lnSpc>
                 <a:spcPct val="140000"/>
               </a:lnSpc>
@@ -6752,7 +6595,7 @@
             <a:endParaRPr lang="en-US" sz="1400" dirty="0"/>
           </a:p>
           <a:p>
-            <a:pPr indent="0" marL="0">
+            <a:pPr marL="0" indent="0">
               <a:lnSpc>
                 <a:spcPct val="140000"/>
               </a:lnSpc>
@@ -6772,7 +6615,7 @@
             <a:endParaRPr lang="en-US" sz="1400" dirty="0"/>
           </a:p>
           <a:p>
-            <a:pPr indent="0" marL="0">
+            <a:pPr marL="0" indent="0">
               <a:lnSpc>
                 <a:spcPct val="140000"/>
               </a:lnSpc>
@@ -6781,7 +6624,7 @@
             <a:endParaRPr lang="en-US" sz="1400" dirty="0"/>
           </a:p>
           <a:p>
-            <a:pPr indent="0" marL="0">
+            <a:pPr marL="0" indent="0">
               <a:lnSpc>
                 <a:spcPct val="140000"/>
               </a:lnSpc>
@@ -6850,7 +6693,7 @@
           <a:bodyPr wrap="square" rtlCol="0" anchor="ctr"/>
           <a:lstStyle/>
           <a:p>
-            <a:pPr algn="ctr" indent="0" marL="0">
+            <a:pPr marL="0" indent="0" algn="ctr">
               <a:buNone/>
             </a:pPr>
             <a:r>
@@ -6889,7 +6732,7 @@
           <a:bodyPr wrap="square" rtlCol="0" anchor="ctr"/>
           <a:lstStyle/>
           <a:p>
-            <a:pPr algn="ctr" indent="0" marL="0">
+            <a:pPr marL="0" indent="0" algn="ctr">
               <a:buNone/>
             </a:pPr>
             <a:r>
@@ -6928,7 +6771,7 @@
           <a:bodyPr wrap="square" rtlCol="0" anchor="ctr"/>
           <a:lstStyle/>
           <a:p>
-            <a:pPr algn="ctr" indent="0" marL="0">
+            <a:pPr marL="0" indent="0" algn="ctr">
               <a:buNone/>
             </a:pPr>
             <a:r>
@@ -6948,14 +6791,14 @@
       </p:sp>
       <p:pic>
         <p:nvPicPr>
-          <p:cNvPr id="9" name="Image 0" descr="/sessions/sleepy-zen-cray/mnt/outputs/deck_assets/logo_var2_azul.png">    </p:cNvPr>
+          <p:cNvPr id="9" name="Image 0" descr="/sessions/sleepy-zen-cray/mnt/outputs/deck_assets/logo_var2_azul.png"/>
           <p:cNvPicPr>
             <a:picLocks noChangeAspect="1"/>
           </p:cNvPicPr>
           <p:nvPr/>
         </p:nvPicPr>
         <p:blipFill>
-          <a:blip r:embed="rId1"/>
+          <a:blip r:embed="rId3"/>
           <a:stretch>
             <a:fillRect/>
           </a:stretch>
@@ -6972,14 +6815,14 @@
       </p:pic>
       <p:pic>
         <p:nvPicPr>
-          <p:cNvPr id="10" name="Image 1" descr="/sessions/sleepy-zen-cray/mnt/outputs/deck_assets/sello_linea_v1_01.png">    </p:cNvPr>
+          <p:cNvPr id="10" name="Image 1" descr="/sessions/sleepy-zen-cray/mnt/outputs/deck_assets/sello_linea_v1_01.png"/>
           <p:cNvPicPr>
             <a:picLocks noChangeAspect="1"/>
           </p:cNvPicPr>
           <p:nvPr/>
         </p:nvPicPr>
         <p:blipFill>
-          <a:blip r:embed="rId2"/>
+          <a:blip r:embed="rId4"/>
           <a:stretch>
             <a:fillRect/>
           </a:stretch>
@@ -7015,7 +6858,7 @@
           <a:bodyPr wrap="square" rtlCol="0" anchor="ctr"/>
           <a:lstStyle/>
           <a:p>
-            <a:pPr indent="0" marL="0">
+            <a:pPr marL="0" indent="0">
               <a:buNone/>
             </a:pPr>
             <a:r>
@@ -7054,7 +6897,7 @@
           <a:bodyPr wrap="square" rtlCol="0" anchor="ctr"/>
           <a:lstStyle/>
           <a:p>
-            <a:pPr algn="r" indent="0" marL="0">
+            <a:pPr marL="0" indent="0" algn="r">
               <a:buNone/>
             </a:pPr>
             <a:r>
@@ -7088,6 +6931,7 @@
         <a:solidFill>
           <a:srgbClr val="FFFFFF"/>
         </a:solidFill>
+        <a:effectLst/>
       </p:bgPr>
     </p:bg>
     <p:spTree>
@@ -7125,11 +6969,11 @@
           <a:bodyPr wrap="square" rtlCol="0" anchor="ctr"/>
           <a:lstStyle/>
           <a:p>
-            <a:pPr indent="0" marL="0">
-              <a:buNone/>
-            </a:pPr>
-            <a:r>
-              <a:rPr lang="en-US" sz="900" b="1" spc="600" kern="0" dirty="0">
+            <a:pPr marL="0" indent="0">
+              <a:buNone/>
+            </a:pPr>
+            <a:r>
+              <a:rPr lang="en-US" sz="900" b="1" kern="0" spc="600" dirty="0">
                 <a:solidFill>
                   <a:srgbClr val="3D2EE8"/>
                 </a:solidFill>
@@ -7164,7 +7008,7 @@
           <a:bodyPr wrap="square" rtlCol="0" anchor="ctr"/>
           <a:lstStyle/>
           <a:p>
-            <a:pPr indent="0" marL="0">
+            <a:pPr marL="0" indent="0">
               <a:buNone/>
             </a:pPr>
             <a:r>
@@ -7203,7 +7047,7 @@
           <a:bodyPr wrap="square" rtlCol="0" anchor="t"/>
           <a:lstStyle/>
           <a:p>
-            <a:pPr indent="0" marL="0">
+            <a:pPr marL="0" indent="0">
               <a:lnSpc>
                 <a:spcPct val="140000"/>
               </a:lnSpc>
@@ -7223,7 +7067,7 @@
             <a:endParaRPr lang="en-US" sz="1400" dirty="0"/>
           </a:p>
           <a:p>
-            <a:pPr indent="0" marL="0">
+            <a:pPr marL="0" indent="0">
               <a:lnSpc>
                 <a:spcPct val="140000"/>
               </a:lnSpc>
@@ -7232,7 +7076,7 @@
             <a:endParaRPr lang="en-US" sz="1400" dirty="0"/>
           </a:p>
           <a:p>
-            <a:pPr indent="0" marL="0">
+            <a:pPr marL="0" indent="0">
               <a:lnSpc>
                 <a:spcPct val="140000"/>
               </a:lnSpc>
@@ -7252,7 +7096,7 @@
             <a:endParaRPr lang="en-US" sz="1400" dirty="0"/>
           </a:p>
           <a:p>
-            <a:pPr indent="0" marL="0">
+            <a:pPr marL="0" indent="0">
               <a:lnSpc>
                 <a:spcPct val="140000"/>
               </a:lnSpc>
@@ -7272,7 +7116,7 @@
             <a:endParaRPr lang="en-US" sz="1400" dirty="0"/>
           </a:p>
           <a:p>
-            <a:pPr indent="0" marL="0">
+            <a:pPr marL="0" indent="0">
               <a:lnSpc>
                 <a:spcPct val="140000"/>
               </a:lnSpc>
@@ -7292,7 +7136,7 @@
             <a:endParaRPr lang="en-US" sz="1400" dirty="0"/>
           </a:p>
           <a:p>
-            <a:pPr indent="0" marL="0">
+            <a:pPr marL="0" indent="0">
               <a:lnSpc>
                 <a:spcPct val="140000"/>
               </a:lnSpc>
@@ -7301,7 +7145,7 @@
             <a:endParaRPr lang="en-US" sz="1400" dirty="0"/>
           </a:p>
           <a:p>
-            <a:pPr indent="0" marL="0">
+            <a:pPr marL="0" indent="0">
               <a:lnSpc>
                 <a:spcPct val="140000"/>
               </a:lnSpc>
@@ -7321,7 +7165,7 @@
             <a:endParaRPr lang="en-US" sz="1400" dirty="0"/>
           </a:p>
           <a:p>
-            <a:pPr indent="0" marL="0">
+            <a:pPr marL="0" indent="0">
               <a:lnSpc>
                 <a:spcPct val="140000"/>
               </a:lnSpc>
@@ -7341,7 +7185,7 @@
             <a:endParaRPr lang="en-US" sz="1400" dirty="0"/>
           </a:p>
           <a:p>
-            <a:pPr indent="0" marL="0">
+            <a:pPr marL="0" indent="0">
               <a:lnSpc>
                 <a:spcPct val="140000"/>
               </a:lnSpc>
@@ -7361,7 +7205,7 @@
             <a:endParaRPr lang="en-US" sz="1400" dirty="0"/>
           </a:p>
           <a:p>
-            <a:pPr indent="0" marL="0">
+            <a:pPr marL="0" indent="0">
               <a:lnSpc>
                 <a:spcPct val="140000"/>
               </a:lnSpc>
@@ -7370,7 +7214,7 @@
             <a:endParaRPr lang="en-US" sz="1400" dirty="0"/>
           </a:p>
           <a:p>
-            <a:pPr indent="0" marL="0">
+            <a:pPr marL="0" indent="0">
               <a:lnSpc>
                 <a:spcPct val="140000"/>
               </a:lnSpc>
@@ -7390,7 +7234,7 @@
             <a:endParaRPr lang="en-US" sz="1400" dirty="0"/>
           </a:p>
           <a:p>
-            <a:pPr indent="0" marL="0">
+            <a:pPr marL="0" indent="0">
               <a:lnSpc>
                 <a:spcPct val="140000"/>
               </a:lnSpc>
@@ -7410,7 +7254,7 @@
             <a:endParaRPr lang="en-US" sz="1400" dirty="0"/>
           </a:p>
           <a:p>
-            <a:pPr indent="0" marL="0">
+            <a:pPr marL="0" indent="0">
               <a:lnSpc>
                 <a:spcPct val="140000"/>
               </a:lnSpc>
@@ -7430,7 +7274,7 @@
             <a:endParaRPr lang="en-US" sz="1400" dirty="0"/>
           </a:p>
           <a:p>
-            <a:pPr indent="0" marL="0">
+            <a:pPr marL="0" indent="0">
               <a:lnSpc>
                 <a:spcPct val="140000"/>
               </a:lnSpc>
@@ -7439,7 +7283,7 @@
             <a:endParaRPr lang="en-US" sz="1400" dirty="0"/>
           </a:p>
           <a:p>
-            <a:pPr indent="0" marL="0">
+            <a:pPr marL="0" indent="0">
               <a:lnSpc>
                 <a:spcPct val="140000"/>
               </a:lnSpc>
@@ -7508,7 +7352,7 @@
           <a:bodyPr wrap="square" rtlCol="0" anchor="ctr"/>
           <a:lstStyle/>
           <a:p>
-            <a:pPr algn="ctr" indent="0" marL="0">
+            <a:pPr marL="0" indent="0" algn="ctr">
               <a:buNone/>
             </a:pPr>
             <a:r>
@@ -7520,7 +7364,23 @@
                 <a:ea typeface="Malgun Gothic" pitchFamily="34" charset="-122"/>
                 <a:cs typeface="Malgun Gothic" pitchFamily="34" charset="-120"/>
               </a:rPr>
-              <a:t>와 / 과 / 하고</a:t>
+              <a:t>와 / 과 </a:t>
+            </a:r>
+          </a:p>
+          <a:p>
+            <a:pPr marL="0" indent="0" algn="ctr">
+              <a:buNone/>
+            </a:pPr>
+            <a:r>
+              <a:rPr lang="en-US" sz="8000" b="1" dirty="0">
+                <a:solidFill>
+                  <a:srgbClr val="FFFFFF"/>
+                </a:solidFill>
+                <a:latin typeface="Malgun Gothic" pitchFamily="34" charset="0"/>
+                <a:ea typeface="Malgun Gothic" pitchFamily="34" charset="-122"/>
+                <a:cs typeface="Malgun Gothic" pitchFamily="34" charset="-120"/>
+              </a:rPr>
+              <a:t>/ 하고</a:t>
             </a:r>
             <a:endParaRPr lang="en-US" sz="8000" dirty="0"/>
           </a:p>
@@ -7547,7 +7407,7 @@
           <a:bodyPr wrap="square" rtlCol="0" anchor="ctr"/>
           <a:lstStyle/>
           <a:p>
-            <a:pPr algn="ctr" indent="0" marL="0">
+            <a:pPr marL="0" indent="0" algn="ctr">
               <a:buNone/>
             </a:pPr>
             <a:r>
@@ -7586,7 +7446,7 @@
           <a:bodyPr wrap="square" rtlCol="0" anchor="ctr"/>
           <a:lstStyle/>
           <a:p>
-            <a:pPr algn="ctr" indent="0" marL="0">
+            <a:pPr marL="0" indent="0" algn="ctr">
               <a:buNone/>
             </a:pPr>
             <a:r>
@@ -7606,14 +7466,14 @@
       </p:sp>
       <p:pic>
         <p:nvPicPr>
-          <p:cNvPr id="9" name="Image 0" descr="/sessions/sleepy-zen-cray/mnt/outputs/deck_assets/logo_var2_azul.png">    </p:cNvPr>
+          <p:cNvPr id="9" name="Image 0" descr="/sessions/sleepy-zen-cray/mnt/outputs/deck_assets/logo_var2_azul.png"/>
           <p:cNvPicPr>
             <a:picLocks noChangeAspect="1"/>
           </p:cNvPicPr>
           <p:nvPr/>
         </p:nvPicPr>
         <p:blipFill>
-          <a:blip r:embed="rId1"/>
+          <a:blip r:embed="rId3"/>
           <a:stretch>
             <a:fillRect/>
           </a:stretch>
@@ -7630,14 +7490,14 @@
       </p:pic>
       <p:pic>
         <p:nvPicPr>
-          <p:cNvPr id="10" name="Image 1" descr="/sessions/sleepy-zen-cray/mnt/outputs/deck_assets/sello_linea_v1_01.png">    </p:cNvPr>
+          <p:cNvPr id="10" name="Image 1" descr="/sessions/sleepy-zen-cray/mnt/outputs/deck_assets/sello_linea_v1_01.png"/>
           <p:cNvPicPr>
             <a:picLocks noChangeAspect="1"/>
           </p:cNvPicPr>
           <p:nvPr/>
         </p:nvPicPr>
         <p:blipFill>
-          <a:blip r:embed="rId2"/>
+          <a:blip r:embed="rId4"/>
           <a:stretch>
             <a:fillRect/>
           </a:stretch>
@@ -7673,7 +7533,7 @@
           <a:bodyPr wrap="square" rtlCol="0" anchor="ctr"/>
           <a:lstStyle/>
           <a:p>
-            <a:pPr indent="0" marL="0">
+            <a:pPr marL="0" indent="0">
               <a:buNone/>
             </a:pPr>
             <a:r>
@@ -7712,7 +7572,7 @@
           <a:bodyPr wrap="square" rtlCol="0" anchor="ctr"/>
           <a:lstStyle/>
           <a:p>
-            <a:pPr algn="r" indent="0" marL="0">
+            <a:pPr marL="0" indent="0" algn="r">
               <a:buNone/>
             </a:pPr>
             <a:r>
@@ -7727,6 +7587,52 @@
               <a:t>SES 08  ·  MULGEONSAGI</a:t>
             </a:r>
             <a:endParaRPr lang="en-US" sz="800" dirty="0"/>
+          </a:p>
+        </p:txBody>
+      </p:sp>
+      <p:sp>
+        <p:nvSpPr>
+          <p:cNvPr id="13" name="TextBox 12">
+            <a:extLst>
+              <a:ext uri="{FF2B5EF4-FFF2-40B4-BE49-F238E27FC236}">
+                <a16:creationId xmlns:a16="http://schemas.microsoft.com/office/drawing/2014/main" id="{0F76FE1C-2848-514A-83E7-4E7A77124F17}"/>
+              </a:ext>
+            </a:extLst>
+          </p:cNvPr>
+          <p:cNvSpPr txBox="1"/>
+          <p:nvPr/>
+        </p:nvSpPr>
+        <p:spPr>
+          <a:xfrm>
+            <a:off x="4712208" y="4511040"/>
+            <a:ext cx="1853392" cy="646331"/>
+          </a:xfrm>
+          <a:prstGeom prst="rect">
+            <a:avLst/>
+          </a:prstGeom>
+          <a:noFill/>
+        </p:spPr>
+        <p:txBody>
+          <a:bodyPr wrap="none" rtlCol="0">
+            <a:spAutoFit/>
+          </a:bodyPr>
+          <a:lstStyle/>
+          <a:p>
+            <a:r>
+              <a:rPr lang="ko-KR" altLang="es-CL" dirty="0"/>
+              <a:t>밥 먹고 자요</a:t>
+            </a:r>
+            <a:r>
+              <a:rPr lang="es-CL" altLang="ko-KR" dirty="0"/>
+              <a:t>.</a:t>
+            </a:r>
+          </a:p>
+          <a:p>
+            <a:r>
+              <a:rPr lang="ko-KR" altLang="es-CL" dirty="0"/>
+              <a:t>수영하고 쉬어요</a:t>
+            </a:r>
+            <a:endParaRPr lang="es-CL" dirty="0"/>
           </a:p>
         </p:txBody>
       </p:sp>
@@ -7746,6 +7652,7 @@
         <a:solidFill>
           <a:srgbClr val="FFFFFF"/>
         </a:solidFill>
+        <a:effectLst/>
       </p:bgPr>
     </p:bg>
     <p:spTree>
@@ -7783,11 +7690,11 @@
           <a:bodyPr wrap="square" rtlCol="0" anchor="ctr"/>
           <a:lstStyle/>
           <a:p>
-            <a:pPr indent="0" marL="0">
-              <a:buNone/>
-            </a:pPr>
-            <a:r>
-              <a:rPr lang="en-US" sz="900" b="1" spc="600" kern="0" dirty="0">
+            <a:pPr marL="0" indent="0">
+              <a:buNone/>
+            </a:pPr>
+            <a:r>
+              <a:rPr lang="en-US" sz="900" b="1" kern="0" spc="600" dirty="0">
                 <a:solidFill>
                   <a:srgbClr val="3D2EE8"/>
                 </a:solidFill>
@@ -7822,7 +7729,7 @@
           <a:bodyPr wrap="square" rtlCol="0" anchor="ctr"/>
           <a:lstStyle/>
           <a:p>
-            <a:pPr indent="0" marL="0">
+            <a:pPr marL="0" indent="0">
               <a:buNone/>
             </a:pPr>
             <a:r>
@@ -7861,7 +7768,7 @@
           <a:bodyPr wrap="square" rtlCol="0" anchor="t"/>
           <a:lstStyle/>
           <a:p>
-            <a:pPr indent="0" marL="0">
+            <a:pPr marL="0" indent="0">
               <a:lnSpc>
                 <a:spcPct val="140000"/>
               </a:lnSpc>
@@ -7881,7 +7788,7 @@
             <a:endParaRPr lang="en-US" sz="1400" dirty="0"/>
           </a:p>
           <a:p>
-            <a:pPr indent="0" marL="0">
+            <a:pPr marL="0" indent="0">
               <a:lnSpc>
                 <a:spcPct val="140000"/>
               </a:lnSpc>
@@ -7890,7 +7797,7 @@
             <a:endParaRPr lang="en-US" sz="1400" dirty="0"/>
           </a:p>
           <a:p>
-            <a:pPr indent="0" marL="0">
+            <a:pPr marL="0" indent="0">
               <a:lnSpc>
                 <a:spcPct val="140000"/>
               </a:lnSpc>
@@ -7910,7 +7817,7 @@
             <a:endParaRPr lang="en-US" sz="1400" dirty="0"/>
           </a:p>
           <a:p>
-            <a:pPr indent="0" marL="0">
+            <a:pPr marL="0" indent="0">
               <a:lnSpc>
                 <a:spcPct val="140000"/>
               </a:lnSpc>
@@ -7919,7 +7826,7 @@
             <a:endParaRPr lang="en-US" sz="1400" dirty="0"/>
           </a:p>
           <a:p>
-            <a:pPr indent="0" marL="0">
+            <a:pPr marL="0" indent="0">
               <a:lnSpc>
                 <a:spcPct val="140000"/>
               </a:lnSpc>
@@ -7939,7 +7846,7 @@
             <a:endParaRPr lang="en-US" sz="1400" dirty="0"/>
           </a:p>
           <a:p>
-            <a:pPr indent="0" marL="0">
+            <a:pPr marL="0" indent="0">
               <a:lnSpc>
                 <a:spcPct val="140000"/>
               </a:lnSpc>
@@ -7959,7 +7866,7 @@
             <a:endParaRPr lang="en-US" sz="1400" dirty="0"/>
           </a:p>
           <a:p>
-            <a:pPr indent="0" marL="0">
+            <a:pPr marL="0" indent="0">
               <a:lnSpc>
                 <a:spcPct val="140000"/>
               </a:lnSpc>
@@ -7979,7 +7886,7 @@
             <a:endParaRPr lang="en-US" sz="1400" dirty="0"/>
           </a:p>
           <a:p>
-            <a:pPr indent="0" marL="0">
+            <a:pPr marL="0" indent="0">
               <a:lnSpc>
                 <a:spcPct val="140000"/>
               </a:lnSpc>
@@ -7999,7 +7906,7 @@
             <a:endParaRPr lang="en-US" sz="1400" dirty="0"/>
           </a:p>
           <a:p>
-            <a:pPr indent="0" marL="0">
+            <a:pPr marL="0" indent="0">
               <a:lnSpc>
                 <a:spcPct val="140000"/>
               </a:lnSpc>
@@ -8019,7 +7926,7 @@
             <a:endParaRPr lang="en-US" sz="1400" dirty="0"/>
           </a:p>
           <a:p>
-            <a:pPr indent="0" marL="0">
+            <a:pPr marL="0" indent="0">
               <a:lnSpc>
                 <a:spcPct val="140000"/>
               </a:lnSpc>
@@ -8039,7 +7946,7 @@
             <a:endParaRPr lang="en-US" sz="1400" dirty="0"/>
           </a:p>
           <a:p>
-            <a:pPr indent="0" marL="0">
+            <a:pPr marL="0" indent="0">
               <a:lnSpc>
                 <a:spcPct val="140000"/>
               </a:lnSpc>
@@ -8048,7 +7955,7 @@
             <a:endParaRPr lang="en-US" sz="1400" dirty="0"/>
           </a:p>
           <a:p>
-            <a:pPr indent="0" marL="0">
+            <a:pPr marL="0" indent="0">
               <a:lnSpc>
                 <a:spcPct val="140000"/>
               </a:lnSpc>
@@ -8117,7 +8024,7 @@
           <a:bodyPr wrap="square" rtlCol="0" anchor="ctr"/>
           <a:lstStyle/>
           <a:p>
-            <a:pPr algn="ctr" indent="0" marL="0">
+            <a:pPr marL="0" indent="0" algn="ctr">
               <a:buNone/>
             </a:pPr>
             <a:r>
@@ -8156,7 +8063,7 @@
           <a:bodyPr wrap="square" rtlCol="0" anchor="ctr"/>
           <a:lstStyle/>
           <a:p>
-            <a:pPr algn="ctr" indent="0" marL="0">
+            <a:pPr marL="0" indent="0" algn="ctr">
               <a:buNone/>
             </a:pPr>
             <a:r>
@@ -8195,7 +8102,7 @@
           <a:bodyPr wrap="square" rtlCol="0" anchor="ctr"/>
           <a:lstStyle/>
           <a:p>
-            <a:pPr algn="ctr" indent="0" marL="0">
+            <a:pPr marL="0" indent="0" algn="ctr">
               <a:buNone/>
             </a:pPr>
             <a:r>
@@ -8215,14 +8122,14 @@
       </p:sp>
       <p:pic>
         <p:nvPicPr>
-          <p:cNvPr id="9" name="Image 0" descr="/sessions/sleepy-zen-cray/mnt/outputs/deck_assets/logo_var2_azul.png">    </p:cNvPr>
+          <p:cNvPr id="9" name="Image 0" descr="/sessions/sleepy-zen-cray/mnt/outputs/deck_assets/logo_var2_azul.png"/>
           <p:cNvPicPr>
             <a:picLocks noChangeAspect="1"/>
           </p:cNvPicPr>
           <p:nvPr/>
         </p:nvPicPr>
         <p:blipFill>
-          <a:blip r:embed="rId1"/>
+          <a:blip r:embed="rId3"/>
           <a:stretch>
             <a:fillRect/>
           </a:stretch>
@@ -8239,14 +8146,14 @@
       </p:pic>
       <p:pic>
         <p:nvPicPr>
-          <p:cNvPr id="10" name="Image 1" descr="/sessions/sleepy-zen-cray/mnt/outputs/deck_assets/sello_linea_v1_01.png">    </p:cNvPr>
+          <p:cNvPr id="10" name="Image 1" descr="/sessions/sleepy-zen-cray/mnt/outputs/deck_assets/sello_linea_v1_01.png"/>
           <p:cNvPicPr>
             <a:picLocks noChangeAspect="1"/>
           </p:cNvPicPr>
           <p:nvPr/>
         </p:nvPicPr>
         <p:blipFill>
-          <a:blip r:embed="rId2"/>
+          <a:blip r:embed="rId4"/>
           <a:stretch>
             <a:fillRect/>
           </a:stretch>
@@ -8282,7 +8189,7 @@
           <a:bodyPr wrap="square" rtlCol="0" anchor="ctr"/>
           <a:lstStyle/>
           <a:p>
-            <a:pPr indent="0" marL="0">
+            <a:pPr marL="0" indent="0">
               <a:buNone/>
             </a:pPr>
             <a:r>
@@ -8321,7 +8228,7 @@
           <a:bodyPr wrap="square" rtlCol="0" anchor="ctr"/>
           <a:lstStyle/>
           <a:p>
-            <a:pPr algn="r" indent="0" marL="0">
+            <a:pPr marL="0" indent="0" algn="r">
               <a:buNone/>
             </a:pPr>
             <a:r>
@@ -8355,6 +8262,7 @@
         <a:solidFill>
           <a:srgbClr val="FFFFFF"/>
         </a:solidFill>
+        <a:effectLst/>
       </p:bgPr>
     </p:bg>
     <p:spTree>
@@ -8392,11 +8300,11 @@
           <a:bodyPr wrap="square" rtlCol="0" anchor="ctr"/>
           <a:lstStyle/>
           <a:p>
-            <a:pPr indent="0" marL="0">
-              <a:buNone/>
-            </a:pPr>
-            <a:r>
-              <a:rPr lang="en-US" sz="900" b="1" spc="600" kern="0" dirty="0">
+            <a:pPr marL="0" indent="0">
+              <a:buNone/>
+            </a:pPr>
+            <a:r>
+              <a:rPr lang="en-US" sz="900" b="1" kern="0" spc="600" dirty="0">
                 <a:solidFill>
                   <a:srgbClr val="FF5C5C"/>
                 </a:solidFill>
@@ -8431,7 +8339,7 @@
           <a:bodyPr wrap="square" rtlCol="0" anchor="ctr"/>
           <a:lstStyle/>
           <a:p>
-            <a:pPr indent="0" marL="0">
+            <a:pPr marL="0" indent="0">
               <a:buNone/>
             </a:pPr>
             <a:r>
@@ -8497,7 +8405,7 @@
           <a:bodyPr wrap="square" rtlCol="0" anchor="ctr"/>
           <a:lstStyle/>
           <a:p>
-            <a:pPr algn="ctr" indent="0" marL="0">
+            <a:pPr marL="0" indent="0" algn="ctr">
               <a:buNone/>
             </a:pPr>
             <a:r>
@@ -8536,7 +8444,7 @@
           <a:bodyPr wrap="square" rtlCol="0" anchor="ctr"/>
           <a:lstStyle/>
           <a:p>
-            <a:pPr algn="ctr" indent="0" marL="0">
+            <a:pPr marL="0" indent="0" algn="ctr">
               <a:buNone/>
             </a:pPr>
             <a:r>
@@ -8602,7 +8510,7 @@
           <a:bodyPr wrap="square" rtlCol="0" anchor="ctr"/>
           <a:lstStyle/>
           <a:p>
-            <a:pPr algn="ctr" indent="0" marL="0">
+            <a:pPr marL="0" indent="0" algn="ctr">
               <a:buNone/>
             </a:pPr>
             <a:r>
@@ -8641,7 +8549,7 @@
           <a:bodyPr wrap="square" rtlCol="0" anchor="ctr"/>
           <a:lstStyle/>
           <a:p>
-            <a:pPr algn="ctr" indent="0" marL="0">
+            <a:pPr marL="0" indent="0" algn="ctr">
               <a:buNone/>
             </a:pPr>
             <a:r>
@@ -8707,7 +8615,7 @@
           <a:bodyPr wrap="square" rtlCol="0" anchor="ctr"/>
           <a:lstStyle/>
           <a:p>
-            <a:pPr algn="ctr" indent="0" marL="0">
+            <a:pPr marL="0" indent="0" algn="ctr">
               <a:buNone/>
             </a:pPr>
             <a:r>
@@ -8746,7 +8654,7 @@
           <a:bodyPr wrap="square" rtlCol="0" anchor="ctr"/>
           <a:lstStyle/>
           <a:p>
-            <a:pPr algn="ctr" indent="0" marL="0">
+            <a:pPr marL="0" indent="0" algn="ctr">
               <a:buNone/>
             </a:pPr>
             <a:r>
@@ -8812,7 +8720,7 @@
           <a:bodyPr wrap="square" rtlCol="0" anchor="ctr"/>
           <a:lstStyle/>
           <a:p>
-            <a:pPr algn="ctr" indent="0" marL="0">
+            <a:pPr marL="0" indent="0" algn="ctr">
               <a:buNone/>
             </a:pPr>
             <a:r>
@@ -8851,7 +8759,7 @@
           <a:bodyPr wrap="square" rtlCol="0" anchor="ctr"/>
           <a:lstStyle/>
           <a:p>
-            <a:pPr algn="ctr" indent="0" marL="0">
+            <a:pPr marL="0" indent="0" algn="ctr">
               <a:buNone/>
             </a:pPr>
             <a:r>
@@ -8917,7 +8825,7 @@
           <a:bodyPr wrap="square" rtlCol="0" anchor="ctr"/>
           <a:lstStyle/>
           <a:p>
-            <a:pPr algn="ctr" indent="0" marL="0">
+            <a:pPr marL="0" indent="0" algn="ctr">
               <a:buNone/>
             </a:pPr>
             <a:r>
@@ -8956,7 +8864,7 @@
           <a:bodyPr wrap="square" rtlCol="0" anchor="ctr"/>
           <a:lstStyle/>
           <a:p>
-            <a:pPr algn="ctr" indent="0" marL="0">
+            <a:pPr marL="0" indent="0" algn="ctr">
               <a:buNone/>
             </a:pPr>
             <a:r>
@@ -9022,7 +8930,7 @@
           <a:bodyPr wrap="square" rtlCol="0" anchor="ctr"/>
           <a:lstStyle/>
           <a:p>
-            <a:pPr algn="ctr" indent="0" marL="0">
+            <a:pPr marL="0" indent="0" algn="ctr">
               <a:buNone/>
             </a:pPr>
             <a:r>
@@ -9061,7 +8969,7 @@
           <a:bodyPr wrap="square" rtlCol="0" anchor="ctr"/>
           <a:lstStyle/>
           <a:p>
-            <a:pPr algn="ctr" indent="0" marL="0">
+            <a:pPr marL="0" indent="0" algn="ctr">
               <a:buNone/>
             </a:pPr>
             <a:r>
@@ -9081,14 +8989,14 @@
       </p:sp>
       <p:pic>
         <p:nvPicPr>
-          <p:cNvPr id="22" name="Image 0" descr="/sessions/sleepy-zen-cray/mnt/outputs/deck_assets/logo_var2_azul.png">    </p:cNvPr>
+          <p:cNvPr id="22" name="Image 0" descr="/sessions/sleepy-zen-cray/mnt/outputs/deck_assets/logo_var2_azul.png"/>
           <p:cNvPicPr>
             <a:picLocks noChangeAspect="1"/>
           </p:cNvPicPr>
           <p:nvPr/>
         </p:nvPicPr>
         <p:blipFill>
-          <a:blip r:embed="rId1"/>
+          <a:blip r:embed="rId3"/>
           <a:stretch>
             <a:fillRect/>
           </a:stretch>
@@ -9105,14 +9013,14 @@
       </p:pic>
       <p:pic>
         <p:nvPicPr>
-          <p:cNvPr id="23" name="Image 1" descr="/sessions/sleepy-zen-cray/mnt/outputs/deck_assets/sello_linea_v1_01.png">    </p:cNvPr>
+          <p:cNvPr id="23" name="Image 1" descr="/sessions/sleepy-zen-cray/mnt/outputs/deck_assets/sello_linea_v1_01.png"/>
           <p:cNvPicPr>
             <a:picLocks noChangeAspect="1"/>
           </p:cNvPicPr>
           <p:nvPr/>
         </p:nvPicPr>
         <p:blipFill>
-          <a:blip r:embed="rId2"/>
+          <a:blip r:embed="rId4"/>
           <a:stretch>
             <a:fillRect/>
           </a:stretch>
@@ -9148,7 +9056,7 @@
           <a:bodyPr wrap="square" rtlCol="0" anchor="ctr"/>
           <a:lstStyle/>
           <a:p>
-            <a:pPr indent="0" marL="0">
+            <a:pPr marL="0" indent="0">
               <a:buNone/>
             </a:pPr>
             <a:r>
@@ -9187,7 +9095,7 @@
           <a:bodyPr wrap="square" rtlCol="0" anchor="ctr"/>
           <a:lstStyle/>
           <a:p>
-            <a:pPr algn="r" indent="0" marL="0">
+            <a:pPr marL="0" indent="0" algn="r">
               <a:buNone/>
             </a:pPr>
             <a:r>
@@ -9506,4 +9414,299 @@
     </a:ext>
   </a:extLst>
 </a:theme>
+</file>
+
+<file path=ppt/theme/theme2.xml><?xml version="1.0" encoding="utf-8"?>
+<a:theme xmlns:a="http://schemas.openxmlformats.org/drawingml/2006/main" name="Office Theme">
+  <a:themeElements>
+    <a:clrScheme name="Office">
+      <a:dk1>
+        <a:sysClr val="windowText" lastClr="000000"/>
+      </a:dk1>
+      <a:lt1>
+        <a:sysClr val="window" lastClr="FFFFFF"/>
+      </a:lt1>
+      <a:dk2>
+        <a:srgbClr val="44546A"/>
+      </a:dk2>
+      <a:lt2>
+        <a:srgbClr val="E7E6E6"/>
+      </a:lt2>
+      <a:accent1>
+        <a:srgbClr val="4472C4"/>
+      </a:accent1>
+      <a:accent2>
+        <a:srgbClr val="ED7D31"/>
+      </a:accent2>
+      <a:accent3>
+        <a:srgbClr val="A5A5A5"/>
+      </a:accent3>
+      <a:accent4>
+        <a:srgbClr val="FFC000"/>
+      </a:accent4>
+      <a:accent5>
+        <a:srgbClr val="5B9BD5"/>
+      </a:accent5>
+      <a:accent6>
+        <a:srgbClr val="70AD47"/>
+      </a:accent6>
+      <a:hlink>
+        <a:srgbClr val="0563C1"/>
+      </a:hlink>
+      <a:folHlink>
+        <a:srgbClr val="954F72"/>
+      </a:folHlink>
+    </a:clrScheme>
+    <a:fontScheme name="Office">
+      <a:majorFont>
+        <a:latin typeface="Calibri Light" panose="020F0302020204030204"/>
+        <a:ea typeface=""/>
+        <a:cs typeface=""/>
+        <a:font script="Jpan" typeface="游ゴシック Light"/>
+        <a:font script="Hang" typeface="맑은 고딕"/>
+        <a:font script="Hans" typeface="等线 Light"/>
+        <a:font script="Hant" typeface="新細明體"/>
+        <a:font script="Arab" typeface="Times New Roman"/>
+        <a:font script="Hebr" typeface="Times New Roman"/>
+        <a:font script="Thai" typeface="Angsana New"/>
+        <a:font script="Ethi" typeface="Nyala"/>
+        <a:font script="Beng" typeface="Vrinda"/>
+        <a:font script="Gujr" typeface="Shruti"/>
+        <a:font script="Khmr" typeface="MoolBoran"/>
+        <a:font script="Knda" typeface="Tunga"/>
+        <a:font script="Guru" typeface="Raavi"/>
+        <a:font script="Cans" typeface="Euphemia"/>
+        <a:font script="Cher" typeface="Plantagenet Cherokee"/>
+        <a:font script="Yiii" typeface="Microsoft Yi Baiti"/>
+        <a:font script="Tibt" typeface="Microsoft Himalaya"/>
+        <a:font script="Thaa" typeface="MV Boli"/>
+        <a:font script="Deva" typeface="Mangal"/>
+        <a:font script="Telu" typeface="Gautami"/>
+        <a:font script="Taml" typeface="Latha"/>
+        <a:font script="Syrc" typeface="Estrangelo Edessa"/>
+        <a:font script="Orya" typeface="Kalinga"/>
+        <a:font script="Mlym" typeface="Kartika"/>
+        <a:font script="Laoo" typeface="DokChampa"/>
+        <a:font script="Sinh" typeface="Iskoola Pota"/>
+        <a:font script="Mong" typeface="Mongolian Baiti"/>
+        <a:font script="Viet" typeface="Times New Roman"/>
+        <a:font script="Uigh" typeface="Microsoft Uighur"/>
+        <a:font script="Geor" typeface="Sylfaen"/>
+        <a:font script="Armn" typeface="Arial"/>
+        <a:font script="Bugi" typeface="Leelawadee UI"/>
+        <a:font script="Bopo" typeface="Microsoft JhengHei"/>
+        <a:font script="Java" typeface="Javanese Text"/>
+        <a:font script="Lisu" typeface="Segoe UI"/>
+        <a:font script="Mymr" typeface="Myanmar Text"/>
+        <a:font script="Nkoo" typeface="Ebrima"/>
+        <a:font script="Olck" typeface="Nirmala UI"/>
+        <a:font script="Osma" typeface="Ebrima"/>
+        <a:font script="Phag" typeface="Phagspa"/>
+        <a:font script="Syrn" typeface="Estrangelo Edessa"/>
+        <a:font script="Syrj" typeface="Estrangelo Edessa"/>
+        <a:font script="Syre" typeface="Estrangelo Edessa"/>
+        <a:font script="Sora" typeface="Nirmala UI"/>
+        <a:font script="Tale" typeface="Microsoft Tai Le"/>
+        <a:font script="Talu" typeface="Microsoft New Tai Lue"/>
+        <a:font script="Tfng" typeface="Ebrima"/>
+      </a:majorFont>
+      <a:minorFont>
+        <a:latin typeface="Calibri" panose="020F0502020204030204"/>
+        <a:ea typeface=""/>
+        <a:cs typeface=""/>
+        <a:font script="Jpan" typeface="游ゴシック"/>
+        <a:font script="Hang" typeface="맑은 고딕"/>
+        <a:font script="Hans" typeface="等线"/>
+        <a:font script="Hant" typeface="新細明體"/>
+        <a:font script="Arab" typeface="Arial"/>
+        <a:font script="Hebr" typeface="Arial"/>
+        <a:font script="Thai" typeface="Cordia New"/>
+        <a:font script="Ethi" typeface="Nyala"/>
+        <a:font script="Beng" typeface="Vrinda"/>
+        <a:font script="Gujr" typeface="Shruti"/>
+        <a:font script="Khmr" typeface="DaunPenh"/>
+        <a:font script="Knda" typeface="Tunga"/>
+        <a:font script="Guru" typeface="Raavi"/>
+        <a:font script="Cans" typeface="Euphemia"/>
+        <a:font script="Cher" typeface="Plantagenet Cherokee"/>
+        <a:font script="Yiii" typeface="Microsoft Yi Baiti"/>
+        <a:font script="Tibt" typeface="Microsoft Himalaya"/>
+        <a:font script="Thaa" typeface="MV Boli"/>
+        <a:font script="Deva" typeface="Mangal"/>
+        <a:font script="Telu" typeface="Gautami"/>
+        <a:font script="Taml" typeface="Latha"/>
+        <a:font script="Syrc" typeface="Estrangelo Edessa"/>
+        <a:font script="Orya" typeface="Kalinga"/>
+        <a:font script="Mlym" typeface="Kartika"/>
+        <a:font script="Laoo" typeface="DokChampa"/>
+        <a:font script="Sinh" typeface="Iskoola Pota"/>
+        <a:font script="Mong" typeface="Mongolian Baiti"/>
+        <a:font script="Viet" typeface="Arial"/>
+        <a:font script="Uigh" typeface="Microsoft Uighur"/>
+        <a:font script="Geor" typeface="Sylfaen"/>
+        <a:font script="Armn" typeface="Arial"/>
+        <a:font script="Bugi" typeface="Leelawadee UI"/>
+        <a:font script="Bopo" typeface="Microsoft JhengHei"/>
+        <a:font script="Java" typeface="Javanese Text"/>
+        <a:font script="Lisu" typeface="Segoe UI"/>
+        <a:font script="Mymr" typeface="Myanmar Text"/>
+        <a:font script="Nkoo" typeface="Ebrima"/>
+        <a:font script="Olck" typeface="Nirmala UI"/>
+        <a:font script="Osma" typeface="Ebrima"/>
+        <a:font script="Phag" typeface="Phagspa"/>
+        <a:font script="Syrn" typeface="Estrangelo Edessa"/>
+        <a:font script="Syrj" typeface="Estrangelo Edessa"/>
+        <a:font script="Syre" typeface="Estrangelo Edessa"/>
+        <a:font script="Sora" typeface="Nirmala UI"/>
+        <a:font script="Tale" typeface="Microsoft Tai Le"/>
+        <a:font script="Talu" typeface="Microsoft New Tai Lue"/>
+        <a:font script="Tfng" typeface="Ebrima"/>
+      </a:minorFont>
+    </a:fontScheme>
+    <a:fmtScheme name="Office">
+      <a:fillStyleLst>
+        <a:solidFill>
+          <a:schemeClr val="phClr"/>
+        </a:solidFill>
+        <a:gradFill rotWithShape="1">
+          <a:gsLst>
+            <a:gs pos="0">
+              <a:schemeClr val="phClr">
+                <a:lumMod val="110000"/>
+                <a:satMod val="105000"/>
+                <a:tint val="67000"/>
+              </a:schemeClr>
+            </a:gs>
+            <a:gs pos="50000">
+              <a:schemeClr val="phClr">
+                <a:lumMod val="105000"/>
+                <a:satMod val="103000"/>
+                <a:tint val="73000"/>
+              </a:schemeClr>
+            </a:gs>
+            <a:gs pos="100000">
+              <a:schemeClr val="phClr">
+                <a:lumMod val="105000"/>
+                <a:satMod val="109000"/>
+                <a:tint val="81000"/>
+              </a:schemeClr>
+            </a:gs>
+          </a:gsLst>
+          <a:lin ang="5400000" scaled="0"/>
+        </a:gradFill>
+        <a:gradFill rotWithShape="1">
+          <a:gsLst>
+            <a:gs pos="0">
+              <a:schemeClr val="phClr">
+                <a:satMod val="103000"/>
+                <a:lumMod val="102000"/>
+                <a:tint val="94000"/>
+              </a:schemeClr>
+            </a:gs>
+            <a:gs pos="50000">
+              <a:schemeClr val="phClr">
+                <a:satMod val="110000"/>
+                <a:lumMod val="100000"/>
+                <a:shade val="100000"/>
+              </a:schemeClr>
+            </a:gs>
+            <a:gs pos="100000">
+              <a:schemeClr val="phClr">
+                <a:lumMod val="99000"/>
+                <a:satMod val="120000"/>
+                <a:shade val="78000"/>
+              </a:schemeClr>
+            </a:gs>
+          </a:gsLst>
+          <a:lin ang="5400000" scaled="0"/>
+        </a:gradFill>
+      </a:fillStyleLst>
+      <a:lnStyleLst>
+        <a:ln w="6350" cap="flat" cmpd="sng" algn="ctr">
+          <a:solidFill>
+            <a:schemeClr val="phClr"/>
+          </a:solidFill>
+          <a:prstDash val="solid"/>
+          <a:miter lim="800000"/>
+        </a:ln>
+        <a:ln w="12700" cap="flat" cmpd="sng" algn="ctr">
+          <a:solidFill>
+            <a:schemeClr val="phClr"/>
+          </a:solidFill>
+          <a:prstDash val="solid"/>
+          <a:miter lim="800000"/>
+        </a:ln>
+        <a:ln w="19050" cap="flat" cmpd="sng" algn="ctr">
+          <a:solidFill>
+            <a:schemeClr val="phClr"/>
+          </a:solidFill>
+          <a:prstDash val="solid"/>
+          <a:miter lim="800000"/>
+        </a:ln>
+      </a:lnStyleLst>
+      <a:effectStyleLst>
+        <a:effectStyle>
+          <a:effectLst/>
+        </a:effectStyle>
+        <a:effectStyle>
+          <a:effectLst/>
+        </a:effectStyle>
+        <a:effectStyle>
+          <a:effectLst>
+            <a:outerShdw blurRad="57150" dist="19050" dir="5400000" algn="ctr" rotWithShape="0">
+              <a:srgbClr val="000000">
+                <a:alpha val="63000"/>
+              </a:srgbClr>
+            </a:outerShdw>
+          </a:effectLst>
+        </a:effectStyle>
+      </a:effectStyleLst>
+      <a:bgFillStyleLst>
+        <a:solidFill>
+          <a:schemeClr val="phClr"/>
+        </a:solidFill>
+        <a:solidFill>
+          <a:schemeClr val="phClr">
+            <a:tint val="95000"/>
+            <a:satMod val="170000"/>
+          </a:schemeClr>
+        </a:solidFill>
+        <a:gradFill rotWithShape="1">
+          <a:gsLst>
+            <a:gs pos="0">
+              <a:schemeClr val="phClr">
+                <a:tint val="93000"/>
+                <a:satMod val="150000"/>
+                <a:shade val="98000"/>
+                <a:lumMod val="102000"/>
+              </a:schemeClr>
+            </a:gs>
+            <a:gs pos="50000">
+              <a:schemeClr val="phClr">
+                <a:tint val="98000"/>
+                <a:satMod val="130000"/>
+                <a:shade val="90000"/>
+                <a:lumMod val="103000"/>
+              </a:schemeClr>
+            </a:gs>
+            <a:gs pos="100000">
+              <a:schemeClr val="phClr">
+                <a:shade val="63000"/>
+                <a:satMod val="120000"/>
+              </a:schemeClr>
+            </a:gs>
+          </a:gsLst>
+          <a:lin ang="5400000" scaled="0"/>
+        </a:gradFill>
+      </a:bgFillStyleLst>
+    </a:fmtScheme>
+  </a:themeElements>
+  <a:objectDefaults/>
+  <a:extraClrSchemeLst/>
+  <a:extLst>
+    <a:ext uri="{05A4C25C-085E-4340-85A3-A5531E510DB2}">
+      <thm15:themeFamily xmlns:thm15="http://schemas.microsoft.com/office/thememl/2012/main" name="Office Theme" id="{62F939B6-93AF-4DB8-9C6B-D6C7DFDC589F}" vid="{4A3C46E8-61CC-4603-A589-7422A47A8E4A}"/>
+    </a:ext>
+  </a:extLst>
+</a:theme>
 </file>
</xml_diff>